<commit_message>
Use the current OneLink Pay logo in submission assets
</commit_message>
<xml_diff>
--- a/docs/OneLink-Pay-UXmaxx-Judge-Deck.pptx
+++ b/docs/OneLink-Pay-UXmaxx-Judge-Deck.pptx
@@ -2,18 +2,18 @@
 <file path=ppt/presentation.xml><?xml version="1.0" encoding="utf-8"?>
 <p:presentation xmlns:p="http://schemas.openxmlformats.org/presentationml/2006/main">
   <p:sldMasterIdLst>
-    <p:sldMasterId xmlns:r="http://schemas.openxmlformats.org/officeDocument/2006/relationships" id="2147483648" r:id="R3d8402b3c8af4ac8"/>
+    <p:sldMasterId xmlns:r="http://schemas.openxmlformats.org/officeDocument/2006/relationships" id="2147483648" r:id="R967792850eca4170"/>
   </p:sldMasterIdLst>
   <p:notesMasterIdLst>
-    <p:notesMasterId xmlns:r="http://schemas.openxmlformats.org/officeDocument/2006/relationships" r:id="Rfd3137b55d314efd"/>
+    <p:notesMasterId xmlns:r="http://schemas.openxmlformats.org/officeDocument/2006/relationships" r:id="Rc878c76ec425456c"/>
   </p:notesMasterIdLst>
   <p:sldIdLst>
-    <p:sldId xmlns:r="http://schemas.openxmlformats.org/officeDocument/2006/relationships" id="256" r:id="Rbaed75f289454907"/>
-    <p:sldId xmlns:r="http://schemas.openxmlformats.org/officeDocument/2006/relationships" id="257" r:id="R9a01990f55414d2b"/>
-    <p:sldId xmlns:r="http://schemas.openxmlformats.org/officeDocument/2006/relationships" id="258" r:id="R9d164431c6b9428a"/>
-    <p:sldId xmlns:r="http://schemas.openxmlformats.org/officeDocument/2006/relationships" id="259" r:id="Recea41e4bb434dd0"/>
-    <p:sldId xmlns:r="http://schemas.openxmlformats.org/officeDocument/2006/relationships" id="260" r:id="R3a6cbe89365b4491"/>
-    <p:sldId xmlns:r="http://schemas.openxmlformats.org/officeDocument/2006/relationships" id="261" r:id="R72dc3de9c1a04651"/>
+    <p:sldId xmlns:r="http://schemas.openxmlformats.org/officeDocument/2006/relationships" id="256" r:id="Rb2acd868d085499c"/>
+    <p:sldId xmlns:r="http://schemas.openxmlformats.org/officeDocument/2006/relationships" id="257" r:id="Rc1aa5dc9c520403a"/>
+    <p:sldId xmlns:r="http://schemas.openxmlformats.org/officeDocument/2006/relationships" id="258" r:id="Ra2a04e78486f437c"/>
+    <p:sldId xmlns:r="http://schemas.openxmlformats.org/officeDocument/2006/relationships" id="259" r:id="R6104536a71f040d2"/>
+    <p:sldId xmlns:r="http://schemas.openxmlformats.org/officeDocument/2006/relationships" id="260" r:id="Rf2d10d7109414cd5"/>
+    <p:sldId xmlns:r="http://schemas.openxmlformats.org/officeDocument/2006/relationships" id="261" r:id="R70ed0e257dc64063"/>
   </p:sldIdLst>
   <p:sldSz cx="12192000" cy="6858000"/>
   <p:notesSz cx="6858000" cy="9144000"/>
@@ -936,7 +936,7 @@
   </p:cSld>
   <p:clrMap bg1="lt1" tx1="dk1" bg2="lt2" tx2="dk2" accent1="accent1" accent2="accent2" accent3="accent3" accent4="accent4" accent5="accent5" accent6="accent6" hlink="hlink" folHlink="folHlink"/>
   <p:sldLayoutIdLst>
-    <p:sldLayoutId xmlns:r="http://schemas.openxmlformats.org/officeDocument/2006/relationships" id="2147483649" r:id="R5c4a487b9eac4cad"/>
+    <p:sldLayoutId xmlns:r="http://schemas.openxmlformats.org/officeDocument/2006/relationships" id="2147483649" r:id="Rec2bd7af0e524f17"/>
   </p:sldLayoutIdLst>
   <p:txStyles>
     <p:titleStyle>
@@ -1484,14 +1484,14 @@
       </p:grpSpPr>
       <p:pic>
         <p:nvPicPr>
-          <p:cNvPr id="5" name=""/>
+          <p:cNvPr id="6" name=""/>
           <p:cNvPicPr>
             <a:picLocks xmlns:a="http://schemas.openxmlformats.org/drawingml/2006/main" noChangeAspect="1"/>
           </p:cNvPicPr>
           <p:nvPr/>
         </p:nvPicPr>
         <p:blipFill>
-          <a:blip xmlns:r="http://schemas.openxmlformats.org/officeDocument/2006/relationships" xmlns:a="http://schemas.openxmlformats.org/drawingml/2006/main" r:embed="R53b1f3358e7b4b06"/>
+          <a:blip xmlns:r="http://schemas.openxmlformats.org/officeDocument/2006/relationships" xmlns:a="http://schemas.openxmlformats.org/drawingml/2006/main" r:embed="R9dc949a6bda04488"/>
           <a:srcRect xmlns:a="http://schemas.openxmlformats.org/drawingml/2006/main" l="0" t="0" r="0" b="0"/>
           <a:stretch xmlns:a="http://schemas.openxmlformats.org/drawingml/2006/main">
             <a:fillRect l="0" t="0" r="0" b="0"/>
@@ -1507,12 +1507,34 @@
           </a:prstGeom>
         </p:spPr>
       </p:pic>
-      <p:sp>
-        <p:nvSpPr>
-          <p:cNvPr id="2" name="">
-            <a:extLst xmlns:a="http://schemas.openxmlformats.org/drawingml/2006/main">
-              <a:ext uri="{FF2B5EF4-FFF2-40B4-BE49-F238E27FC236}">
-                <a16:creationId xmlns:a16="http://schemas.microsoft.com/office/drawing/2014/main" id="{143E9773-B1D8-42A4-8DEB-CE709C99A1F5}"/>
+      <p:pic>
+        <p:nvPicPr>
+          <p:cNvPr id="7" name=""/>
+          <p:cNvPicPr>
+            <a:picLocks xmlns:a="http://schemas.openxmlformats.org/drawingml/2006/main" noChangeAspect="1"/>
+          </p:cNvPicPr>
+          <p:nvPr/>
+        </p:nvPicPr>
+        <p:blipFill>
+          <a:blip xmlns:r="http://schemas.openxmlformats.org/officeDocument/2006/relationships" xmlns:a="http://schemas.openxmlformats.org/drawingml/2006/main" r:embed="Rba1b19d53bb047e6"/>
+          <a:stretch xmlns:a="http://schemas.openxmlformats.org/drawingml/2006/main"/>
+        </p:blipFill>
+        <p:spPr>
+          <a:xfrm xmlns:a="http://schemas.openxmlformats.org/drawingml/2006/main">
+            <a:off x="2438400" y="2628900"/>
+            <a:ext cx="1447800" cy="1447800"/>
+          </a:xfrm>
+          <a:prstGeom xmlns:a="http://schemas.openxmlformats.org/drawingml/2006/main" prst="rect">
+            <a:avLst/>
+          </a:prstGeom>
+        </p:spPr>
+      </p:pic>
+      <p:sp>
+        <p:nvSpPr>
+          <p:cNvPr id="3" name="">
+            <a:extLst xmlns:a="http://schemas.openxmlformats.org/drawingml/2006/main">
+              <a:ext uri="{FF2B5EF4-FFF2-40B4-BE49-F238E27FC236}">
+                <a16:creationId xmlns:a16="http://schemas.microsoft.com/office/drawing/2014/main" id="{BD6272FE-9D15-48F0-82BF-BB434C9B90F6}"/>
               </a:ext>
             </a:extLst>
           </p:cNvPr>
@@ -1540,10 +1562,10 @@
       </p:sp>
       <p:sp>
         <p:nvSpPr>
-          <p:cNvPr id="3" name="">
-            <a:extLst xmlns:a="http://schemas.openxmlformats.org/drawingml/2006/main">
-              <a:ext uri="{FF2B5EF4-FFF2-40B4-BE49-F238E27FC236}">
-                <a16:creationId xmlns:a16="http://schemas.microsoft.com/office/drawing/2014/main" id="{EA6C2EB3-82B3-4008-95CD-95B82BBC9280}"/>
+          <p:cNvPr id="4" name="">
+            <a:extLst xmlns:a="http://schemas.openxmlformats.org/drawingml/2006/main">
+              <a:ext uri="{FF2B5EF4-FFF2-40B4-BE49-F238E27FC236}">
+                <a16:creationId xmlns:a16="http://schemas.microsoft.com/office/drawing/2014/main" id="{21295BB1-9846-4DA9-B6F2-128A6D179143}"/>
               </a:ext>
             </a:extLst>
           </p:cNvPr>
@@ -1598,10 +1620,10 @@
       </p:sp>
       <p:sp>
         <p:nvSpPr>
-          <p:cNvPr id="4" name="">
-            <a:extLst xmlns:a="http://schemas.openxmlformats.org/drawingml/2006/main">
-              <a:ext uri="{FF2B5EF4-FFF2-40B4-BE49-F238E27FC236}">
-                <a16:creationId xmlns:a16="http://schemas.microsoft.com/office/drawing/2014/main" id="{81E2C4C3-6E6E-47EF-AAAF-2E645C26B94E}"/>
+          <p:cNvPr id="5" name="">
+            <a:extLst xmlns:a="http://schemas.openxmlformats.org/drawingml/2006/main">
+              <a:ext uri="{FF2B5EF4-FFF2-40B4-BE49-F238E27FC236}">
+                <a16:creationId xmlns:a16="http://schemas.microsoft.com/office/drawing/2014/main" id="{6938DB72-8CF6-449F-9B1B-BBED567130D0}"/>
               </a:ext>
             </a:extLst>
           </p:cNvPr>
@@ -1648,7 +1670,7 @@
                 <a:latin typeface="Aptos"/>
                 <a:ea typeface="Aptos"/>
                 <a:cs typeface="Aptos"/>
-                <a:hlinkClick xmlns:r="http://schemas.openxmlformats.org/officeDocument/2006/relationships" r:id="R7c27d40fda1941ec"/>
+                <a:hlinkClick xmlns:r="http://schemas.openxmlformats.org/officeDocument/2006/relationships" r:id="R0a04a42a6ec54eda"/>
               </a:rPr>
               <a:t>Demo: youtu.be/LSkvvrFh4n4</a:t>
             </a:r>
@@ -1658,7 +1680,7 @@
     </p:spTree>
     <p:extLst>
       <p:ext uri="{BB962C8B-B14F-4D97-AF65-F5344CB8AC3E}">
-        <p14:creationId xmlns:p14="http://schemas.microsoft.com/office/powerpoint/2010/main" val="1459823038"/>
+        <p14:creationId xmlns:p14="http://schemas.microsoft.com/office/powerpoint/2010/main" val="883308061"/>
       </p:ext>
     </p:extLst>
   </p:cSld>
@@ -1693,7 +1715,7 @@
           <p:nvPr/>
         </p:nvPicPr>
         <p:blipFill>
-          <a:blip xmlns:r="http://schemas.openxmlformats.org/officeDocument/2006/relationships" xmlns:a="http://schemas.openxmlformats.org/drawingml/2006/main" r:embed="R7556c223fcce4579"/>
+          <a:blip xmlns:r="http://schemas.openxmlformats.org/officeDocument/2006/relationships" xmlns:a="http://schemas.openxmlformats.org/drawingml/2006/main" r:embed="R7beca1cebbaf4ce9"/>
           <a:stretch xmlns:a="http://schemas.openxmlformats.org/drawingml/2006/main"/>
         </p:blipFill>
         <p:spPr>
@@ -1711,7 +1733,7 @@
           <p:cNvPr id="2" name="">
             <a:extLst xmlns:a="http://schemas.openxmlformats.org/drawingml/2006/main">
               <a:ext uri="{FF2B5EF4-FFF2-40B4-BE49-F238E27FC236}">
-                <a16:creationId xmlns:a16="http://schemas.microsoft.com/office/drawing/2014/main" id="{C51EEB01-D156-4EF5-ADB5-77BA8A8492B4}"/>
+                <a16:creationId xmlns:a16="http://schemas.microsoft.com/office/drawing/2014/main" id="{F11ED5F9-54F0-490E-B8E0-6859D7513277}"/>
               </a:ext>
             </a:extLst>
           </p:cNvPr>
@@ -1769,7 +1791,7 @@
           <p:cNvPr id="3" name="">
             <a:extLst xmlns:a="http://schemas.openxmlformats.org/drawingml/2006/main">
               <a:ext uri="{FF2B5EF4-FFF2-40B4-BE49-F238E27FC236}">
-                <a16:creationId xmlns:a16="http://schemas.microsoft.com/office/drawing/2014/main" id="{6B2A1E4C-22AA-44BE-9FEB-C4FCE21B010B}"/>
+                <a16:creationId xmlns:a16="http://schemas.microsoft.com/office/drawing/2014/main" id="{CE277512-47A0-4AF9-BBC4-7200A93D7453}"/>
               </a:ext>
             </a:extLst>
           </p:cNvPr>
@@ -1827,7 +1849,7 @@
           <p:cNvPr id="4" name="">
             <a:extLst xmlns:a="http://schemas.openxmlformats.org/drawingml/2006/main">
               <a:ext uri="{FF2B5EF4-FFF2-40B4-BE49-F238E27FC236}">
-                <a16:creationId xmlns:a16="http://schemas.microsoft.com/office/drawing/2014/main" id="{2C01A456-ACC9-4022-9644-C8D8C58EEA6B}"/>
+                <a16:creationId xmlns:a16="http://schemas.microsoft.com/office/drawing/2014/main" id="{BA0508C0-A1C6-49D7-9CED-BB2D30339A95}"/>
               </a:ext>
             </a:extLst>
           </p:cNvPr>
@@ -1885,7 +1907,7 @@
           <p:cNvPr id="5" name="">
             <a:extLst xmlns:a="http://schemas.openxmlformats.org/drawingml/2006/main">
               <a:ext uri="{FF2B5EF4-FFF2-40B4-BE49-F238E27FC236}">
-                <a16:creationId xmlns:a16="http://schemas.microsoft.com/office/drawing/2014/main" id="{F9D1090B-D05B-4811-BEEE-2B1DECB65EF3}"/>
+                <a16:creationId xmlns:a16="http://schemas.microsoft.com/office/drawing/2014/main" id="{3600FAAB-FC36-479C-BEE4-22BF2E55705D}"/>
               </a:ext>
             </a:extLst>
           </p:cNvPr>
@@ -1943,7 +1965,7 @@
           <p:cNvPr id="6" name="">
             <a:extLst xmlns:a="http://schemas.openxmlformats.org/drawingml/2006/main">
               <a:ext uri="{FF2B5EF4-FFF2-40B4-BE49-F238E27FC236}">
-                <a16:creationId xmlns:a16="http://schemas.microsoft.com/office/drawing/2014/main" id="{EA80F51B-38FD-4483-8ED0-2767290C0513}"/>
+                <a16:creationId xmlns:a16="http://schemas.microsoft.com/office/drawing/2014/main" id="{79268436-87A1-4435-B853-2794256C6AF8}"/>
               </a:ext>
             </a:extLst>
           </p:cNvPr>
@@ -2001,7 +2023,7 @@
           <p:cNvPr id="7" name="">
             <a:extLst xmlns:a="http://schemas.openxmlformats.org/drawingml/2006/main">
               <a:ext uri="{FF2B5EF4-FFF2-40B4-BE49-F238E27FC236}">
-                <a16:creationId xmlns:a16="http://schemas.microsoft.com/office/drawing/2014/main" id="{ADA881B4-A804-4144-A2A4-DF5F56852D35}"/>
+                <a16:creationId xmlns:a16="http://schemas.microsoft.com/office/drawing/2014/main" id="{2EFC1EBA-D14C-43ED-A632-953BD39965F6}"/>
               </a:ext>
             </a:extLst>
           </p:cNvPr>
@@ -2036,7 +2058,7 @@
           <p:cNvPr id="8" name="">
             <a:extLst xmlns:a="http://schemas.openxmlformats.org/drawingml/2006/main">
               <a:ext uri="{FF2B5EF4-FFF2-40B4-BE49-F238E27FC236}">
-                <a16:creationId xmlns:a16="http://schemas.microsoft.com/office/drawing/2014/main" id="{A7A9C206-3849-4C89-9E92-85CADC1F3A46}"/>
+                <a16:creationId xmlns:a16="http://schemas.microsoft.com/office/drawing/2014/main" id="{39F0F1C4-5713-4C98-A431-AF362484F124}"/>
               </a:ext>
             </a:extLst>
           </p:cNvPr>
@@ -2094,7 +2116,7 @@
           <p:cNvPr id="9" name="">
             <a:extLst xmlns:a="http://schemas.openxmlformats.org/drawingml/2006/main">
               <a:ext uri="{FF2B5EF4-FFF2-40B4-BE49-F238E27FC236}">
-                <a16:creationId xmlns:a16="http://schemas.microsoft.com/office/drawing/2014/main" id="{92AADD10-106A-497D-BD9E-0732F213A4E7}"/>
+                <a16:creationId xmlns:a16="http://schemas.microsoft.com/office/drawing/2014/main" id="{E0E2B22E-01B5-4B7D-B919-958CADFA7D0F}"/>
               </a:ext>
             </a:extLst>
           </p:cNvPr>
@@ -2152,7 +2174,7 @@
           <p:cNvPr id="10" name="">
             <a:extLst xmlns:a="http://schemas.openxmlformats.org/drawingml/2006/main">
               <a:ext uri="{FF2B5EF4-FFF2-40B4-BE49-F238E27FC236}">
-                <a16:creationId xmlns:a16="http://schemas.microsoft.com/office/drawing/2014/main" id="{E5AF74C9-26C6-443F-B113-263F1F00D76B}"/>
+                <a16:creationId xmlns:a16="http://schemas.microsoft.com/office/drawing/2014/main" id="{484BC162-5E7D-4BCA-B5BC-FD8C312FB600}"/>
               </a:ext>
             </a:extLst>
           </p:cNvPr>
@@ -2210,7 +2232,7 @@
           <p:cNvPr id="11" name="">
             <a:extLst xmlns:a="http://schemas.openxmlformats.org/drawingml/2006/main">
               <a:ext uri="{FF2B5EF4-FFF2-40B4-BE49-F238E27FC236}">
-                <a16:creationId xmlns:a16="http://schemas.microsoft.com/office/drawing/2014/main" id="{6BC53C67-E889-4149-BF04-D1A8BE8F7383}"/>
+                <a16:creationId xmlns:a16="http://schemas.microsoft.com/office/drawing/2014/main" id="{BA4BB2B0-FE00-4A35-AEE3-2AE18FA1533F}"/>
               </a:ext>
             </a:extLst>
           </p:cNvPr>
@@ -2268,7 +2290,7 @@
           <p:cNvPr id="12" name="">
             <a:extLst xmlns:a="http://schemas.openxmlformats.org/drawingml/2006/main">
               <a:ext uri="{FF2B5EF4-FFF2-40B4-BE49-F238E27FC236}">
-                <a16:creationId xmlns:a16="http://schemas.microsoft.com/office/drawing/2014/main" id="{11BF0564-A6AB-4884-BD03-99886B43272A}"/>
+                <a16:creationId xmlns:a16="http://schemas.microsoft.com/office/drawing/2014/main" id="{FF47D129-030B-4968-8936-313C3BF1C752}"/>
               </a:ext>
             </a:extLst>
           </p:cNvPr>
@@ -2303,7 +2325,7 @@
           <p:cNvPr id="13" name="">
             <a:extLst xmlns:a="http://schemas.openxmlformats.org/drawingml/2006/main">
               <a:ext uri="{FF2B5EF4-FFF2-40B4-BE49-F238E27FC236}">
-                <a16:creationId xmlns:a16="http://schemas.microsoft.com/office/drawing/2014/main" id="{DD64F22D-455A-46CA-865D-4E97A5E0E66E}"/>
+                <a16:creationId xmlns:a16="http://schemas.microsoft.com/office/drawing/2014/main" id="{9C5D3CC6-1745-4853-9B64-DD003C3B51C5}"/>
               </a:ext>
             </a:extLst>
           </p:cNvPr>
@@ -2361,7 +2383,7 @@
           <p:cNvPr id="14" name="">
             <a:extLst xmlns:a="http://schemas.openxmlformats.org/drawingml/2006/main">
               <a:ext uri="{FF2B5EF4-FFF2-40B4-BE49-F238E27FC236}">
-                <a16:creationId xmlns:a16="http://schemas.microsoft.com/office/drawing/2014/main" id="{F890AFA1-2696-4874-BD66-C039C000B0EF}"/>
+                <a16:creationId xmlns:a16="http://schemas.microsoft.com/office/drawing/2014/main" id="{163CD321-1F2E-4784-8A08-1FE67F13485A}"/>
               </a:ext>
             </a:extLst>
           </p:cNvPr>
@@ -2419,7 +2441,7 @@
           <p:cNvPr id="15" name="">
             <a:extLst xmlns:a="http://schemas.openxmlformats.org/drawingml/2006/main">
               <a:ext uri="{FF2B5EF4-FFF2-40B4-BE49-F238E27FC236}">
-                <a16:creationId xmlns:a16="http://schemas.microsoft.com/office/drawing/2014/main" id="{A0079AF9-7CE2-4B7C-A8DE-CCD79F3DD02E}"/>
+                <a16:creationId xmlns:a16="http://schemas.microsoft.com/office/drawing/2014/main" id="{125E6D6D-70C9-418B-85B1-3DCC845189BC}"/>
               </a:ext>
             </a:extLst>
           </p:cNvPr>
@@ -2477,7 +2499,7 @@
           <p:cNvPr id="16" name="">
             <a:extLst xmlns:a="http://schemas.openxmlformats.org/drawingml/2006/main">
               <a:ext uri="{FF2B5EF4-FFF2-40B4-BE49-F238E27FC236}">
-                <a16:creationId xmlns:a16="http://schemas.microsoft.com/office/drawing/2014/main" id="{0870AA4F-4915-41D3-973B-D124236C95C7}"/>
+                <a16:creationId xmlns:a16="http://schemas.microsoft.com/office/drawing/2014/main" id="{4160E214-35B7-4160-BBED-5265688EAC4C}"/>
               </a:ext>
             </a:extLst>
           </p:cNvPr>
@@ -2535,7 +2557,7 @@
           <p:cNvPr id="17" name="">
             <a:extLst xmlns:a="http://schemas.openxmlformats.org/drawingml/2006/main">
               <a:ext uri="{FF2B5EF4-FFF2-40B4-BE49-F238E27FC236}">
-                <a16:creationId xmlns:a16="http://schemas.microsoft.com/office/drawing/2014/main" id="{5D7CEEBF-F82D-4460-8E17-084D021ED1AC}"/>
+                <a16:creationId xmlns:a16="http://schemas.microsoft.com/office/drawing/2014/main" id="{0DC5E318-D830-4674-8EEF-A9FDC5F943A2}"/>
               </a:ext>
             </a:extLst>
           </p:cNvPr>
@@ -2591,7 +2613,7 @@
     </p:spTree>
     <p:extLst>
       <p:ext uri="{BB962C8B-B14F-4D97-AF65-F5344CB8AC3E}">
-        <p14:creationId xmlns:p14="http://schemas.microsoft.com/office/powerpoint/2010/main" val="2127278358"/>
+        <p14:creationId xmlns:p14="http://schemas.microsoft.com/office/powerpoint/2010/main" val="1160407314"/>
       </p:ext>
     </p:extLst>
   </p:cSld>
@@ -2626,7 +2648,7 @@
           <p:nvPr/>
         </p:nvPicPr>
         <p:blipFill>
-          <a:blip xmlns:r="http://schemas.openxmlformats.org/officeDocument/2006/relationships" xmlns:a="http://schemas.openxmlformats.org/drawingml/2006/main" r:embed="R3bee64c51e744aac"/>
+          <a:blip xmlns:r="http://schemas.openxmlformats.org/officeDocument/2006/relationships" xmlns:a="http://schemas.openxmlformats.org/drawingml/2006/main" r:embed="Rca9915ea4ac74121"/>
           <a:stretch xmlns:a="http://schemas.openxmlformats.org/drawingml/2006/main"/>
         </p:blipFill>
         <p:spPr>
@@ -2644,7 +2666,7 @@
           <p:cNvPr id="2" name="">
             <a:extLst xmlns:a="http://schemas.openxmlformats.org/drawingml/2006/main">
               <a:ext uri="{FF2B5EF4-FFF2-40B4-BE49-F238E27FC236}">
-                <a16:creationId xmlns:a16="http://schemas.microsoft.com/office/drawing/2014/main" id="{7202AE24-D175-4E90-B7AE-2F365EDFEA42}"/>
+                <a16:creationId xmlns:a16="http://schemas.microsoft.com/office/drawing/2014/main" id="{58AFC618-7BB0-44F6-B3CC-F190E6F70FBF}"/>
               </a:ext>
             </a:extLst>
           </p:cNvPr>
@@ -2702,7 +2724,7 @@
           <p:cNvPr id="3" name="">
             <a:extLst xmlns:a="http://schemas.openxmlformats.org/drawingml/2006/main">
               <a:ext uri="{FF2B5EF4-FFF2-40B4-BE49-F238E27FC236}">
-                <a16:creationId xmlns:a16="http://schemas.microsoft.com/office/drawing/2014/main" id="{062C26B1-4263-49F0-A22E-33CEA65A9D0D}"/>
+                <a16:creationId xmlns:a16="http://schemas.microsoft.com/office/drawing/2014/main" id="{13ED1848-E0FC-45B7-8227-382E1993784D}"/>
               </a:ext>
             </a:extLst>
           </p:cNvPr>
@@ -2760,7 +2782,7 @@
           <p:cNvPr id="4" name="">
             <a:extLst xmlns:a="http://schemas.openxmlformats.org/drawingml/2006/main">
               <a:ext uri="{FF2B5EF4-FFF2-40B4-BE49-F238E27FC236}">
-                <a16:creationId xmlns:a16="http://schemas.microsoft.com/office/drawing/2014/main" id="{9E73FDED-341D-4BCD-933C-04E712F9822F}"/>
+                <a16:creationId xmlns:a16="http://schemas.microsoft.com/office/drawing/2014/main" id="{74C59953-7CA9-48C0-87C7-5191B7D8FED9}"/>
               </a:ext>
             </a:extLst>
           </p:cNvPr>
@@ -2818,7 +2840,7 @@
           <p:cNvPr id="5" name="">
             <a:extLst xmlns:a="http://schemas.openxmlformats.org/drawingml/2006/main">
               <a:ext uri="{FF2B5EF4-FFF2-40B4-BE49-F238E27FC236}">
-                <a16:creationId xmlns:a16="http://schemas.microsoft.com/office/drawing/2014/main" id="{5A890E66-0292-4333-BEDC-EF9AEE6DA6FC}"/>
+                <a16:creationId xmlns:a16="http://schemas.microsoft.com/office/drawing/2014/main" id="{49C176AA-C3E2-4F19-AA78-9127D0B886DE}"/>
               </a:ext>
             </a:extLst>
           </p:cNvPr>
@@ -2876,7 +2898,7 @@
           <p:cNvPr id="6" name="">
             <a:extLst xmlns:a="http://schemas.openxmlformats.org/drawingml/2006/main">
               <a:ext uri="{FF2B5EF4-FFF2-40B4-BE49-F238E27FC236}">
-                <a16:creationId xmlns:a16="http://schemas.microsoft.com/office/drawing/2014/main" id="{60D0C616-34CD-4B29-89E1-93F3132073C6}"/>
+                <a16:creationId xmlns:a16="http://schemas.microsoft.com/office/drawing/2014/main" id="{C3E4E5A7-DEA4-4822-8EFF-671A159E2C50}"/>
               </a:ext>
             </a:extLst>
           </p:cNvPr>
@@ -2934,7 +2956,7 @@
           <p:cNvPr id="7" name="">
             <a:extLst xmlns:a="http://schemas.openxmlformats.org/drawingml/2006/main">
               <a:ext uri="{FF2B5EF4-FFF2-40B4-BE49-F238E27FC236}">
-                <a16:creationId xmlns:a16="http://schemas.microsoft.com/office/drawing/2014/main" id="{DF38599B-AC0D-4B4F-AB96-C43AECB6FC09}"/>
+                <a16:creationId xmlns:a16="http://schemas.microsoft.com/office/drawing/2014/main" id="{73019B17-5627-4DC9-AB74-A383D391D97F}"/>
               </a:ext>
             </a:extLst>
           </p:cNvPr>
@@ -2973,7 +2995,7 @@
           <p:nvPr/>
         </p:nvPicPr>
         <p:blipFill>
-          <a:blip xmlns:r="http://schemas.openxmlformats.org/officeDocument/2006/relationships" xmlns:a="http://schemas.openxmlformats.org/drawingml/2006/main" r:embed="Rbaedac9bee8e4993"/>
+          <a:blip xmlns:r="http://schemas.openxmlformats.org/officeDocument/2006/relationships" xmlns:a="http://schemas.openxmlformats.org/drawingml/2006/main" r:embed="R7020d0870a904fab"/>
           <a:srcRect xmlns:a="http://schemas.openxmlformats.org/drawingml/2006/main" l="0" t="13676" r="0" b="13676"/>
           <a:stretch xmlns:a="http://schemas.openxmlformats.org/drawingml/2006/main">
             <a:fillRect l="0" t="0" r="0" b="0"/>
@@ -2996,7 +3018,7 @@
           <p:cNvPr id="9" name="">
             <a:extLst xmlns:a="http://schemas.openxmlformats.org/drawingml/2006/main">
               <a:ext uri="{FF2B5EF4-FFF2-40B4-BE49-F238E27FC236}">
-                <a16:creationId xmlns:a16="http://schemas.microsoft.com/office/drawing/2014/main" id="{3A639637-A95A-4A2F-8C10-7369AFB382E7}"/>
+                <a16:creationId xmlns:a16="http://schemas.microsoft.com/office/drawing/2014/main" id="{B9724DFB-6758-4CF9-BB58-41C593ABE96E}"/>
               </a:ext>
             </a:extLst>
           </p:cNvPr>
@@ -3054,7 +3076,7 @@
           <p:cNvPr id="10" name="">
             <a:extLst xmlns:a="http://schemas.openxmlformats.org/drawingml/2006/main">
               <a:ext uri="{FF2B5EF4-FFF2-40B4-BE49-F238E27FC236}">
-                <a16:creationId xmlns:a16="http://schemas.microsoft.com/office/drawing/2014/main" id="{4C7D9CC0-4397-419D-95D0-BBF028F13E96}"/>
+                <a16:creationId xmlns:a16="http://schemas.microsoft.com/office/drawing/2014/main" id="{48E1FA3A-9449-4CA9-9DA2-93E6FD06E19A}"/>
               </a:ext>
             </a:extLst>
           </p:cNvPr>
@@ -3112,7 +3134,7 @@
           <p:cNvPr id="11" name="">
             <a:extLst xmlns:a="http://schemas.openxmlformats.org/drawingml/2006/main">
               <a:ext uri="{FF2B5EF4-FFF2-40B4-BE49-F238E27FC236}">
-                <a16:creationId xmlns:a16="http://schemas.microsoft.com/office/drawing/2014/main" id="{9D266732-5CD7-45EB-9944-B41D222541B6}"/>
+                <a16:creationId xmlns:a16="http://schemas.microsoft.com/office/drawing/2014/main" id="{4B9B1816-8F1F-4C95-8F19-B7AA4540C82C}"/>
               </a:ext>
             </a:extLst>
           </p:cNvPr>
@@ -3170,7 +3192,7 @@
           <p:cNvPr id="12" name="">
             <a:extLst xmlns:a="http://schemas.openxmlformats.org/drawingml/2006/main">
               <a:ext uri="{FF2B5EF4-FFF2-40B4-BE49-F238E27FC236}">
-                <a16:creationId xmlns:a16="http://schemas.microsoft.com/office/drawing/2014/main" id="{F1876DDC-977B-413F-A889-3E855A06DAD1}"/>
+                <a16:creationId xmlns:a16="http://schemas.microsoft.com/office/drawing/2014/main" id="{7202D2FF-AA30-4146-A761-A47754D8DBCD}"/>
               </a:ext>
             </a:extLst>
           </p:cNvPr>
@@ -3228,7 +3250,7 @@
           <p:cNvPr id="13" name="">
             <a:extLst xmlns:a="http://schemas.openxmlformats.org/drawingml/2006/main">
               <a:ext uri="{FF2B5EF4-FFF2-40B4-BE49-F238E27FC236}">
-                <a16:creationId xmlns:a16="http://schemas.microsoft.com/office/drawing/2014/main" id="{D7E7AD08-1A31-45FB-AAEA-65EE3DC24EA0}"/>
+                <a16:creationId xmlns:a16="http://schemas.microsoft.com/office/drawing/2014/main" id="{025A5094-1C75-45BF-B2C1-E83635969E7B}"/>
               </a:ext>
             </a:extLst>
           </p:cNvPr>
@@ -3286,7 +3308,7 @@
           <p:cNvPr id="14" name="">
             <a:extLst xmlns:a="http://schemas.openxmlformats.org/drawingml/2006/main">
               <a:ext uri="{FF2B5EF4-FFF2-40B4-BE49-F238E27FC236}">
-                <a16:creationId xmlns:a16="http://schemas.microsoft.com/office/drawing/2014/main" id="{713066CB-6D6B-4141-9654-C88D79BF1CA4}"/>
+                <a16:creationId xmlns:a16="http://schemas.microsoft.com/office/drawing/2014/main" id="{D29AD5B4-4E69-4C96-BC50-13426F047175}"/>
               </a:ext>
             </a:extLst>
           </p:cNvPr>
@@ -3344,7 +3366,7 @@
           <p:cNvPr id="15" name="">
             <a:extLst xmlns:a="http://schemas.openxmlformats.org/drawingml/2006/main">
               <a:ext uri="{FF2B5EF4-FFF2-40B4-BE49-F238E27FC236}">
-                <a16:creationId xmlns:a16="http://schemas.microsoft.com/office/drawing/2014/main" id="{3CCC96C9-A0FC-42C2-B20C-ACB28B54A863}"/>
+                <a16:creationId xmlns:a16="http://schemas.microsoft.com/office/drawing/2014/main" id="{2FD84690-9154-4B68-BB6F-29EF374AA5EB}"/>
               </a:ext>
             </a:extLst>
           </p:cNvPr>
@@ -3402,7 +3424,7 @@
           <p:cNvPr id="16" name="">
             <a:extLst xmlns:a="http://schemas.openxmlformats.org/drawingml/2006/main">
               <a:ext uri="{FF2B5EF4-FFF2-40B4-BE49-F238E27FC236}">
-                <a16:creationId xmlns:a16="http://schemas.microsoft.com/office/drawing/2014/main" id="{8A3977D2-9FA7-451E-9614-728827BE9324}"/>
+                <a16:creationId xmlns:a16="http://schemas.microsoft.com/office/drawing/2014/main" id="{2813A28D-8C70-40AF-9211-88DE2858DB88}"/>
               </a:ext>
             </a:extLst>
           </p:cNvPr>
@@ -3460,7 +3482,7 @@
           <p:cNvPr id="17" name="">
             <a:extLst xmlns:a="http://schemas.openxmlformats.org/drawingml/2006/main">
               <a:ext uri="{FF2B5EF4-FFF2-40B4-BE49-F238E27FC236}">
-                <a16:creationId xmlns:a16="http://schemas.microsoft.com/office/drawing/2014/main" id="{2BE3BCAA-7CA4-48F1-AEA5-D3C0866B732A}"/>
+                <a16:creationId xmlns:a16="http://schemas.microsoft.com/office/drawing/2014/main" id="{BFB0481D-92B6-4D69-B6B4-EAB716303C6E}"/>
               </a:ext>
             </a:extLst>
           </p:cNvPr>
@@ -3518,7 +3540,7 @@
           <p:cNvPr id="18" name="">
             <a:extLst xmlns:a="http://schemas.openxmlformats.org/drawingml/2006/main">
               <a:ext uri="{FF2B5EF4-FFF2-40B4-BE49-F238E27FC236}">
-                <a16:creationId xmlns:a16="http://schemas.microsoft.com/office/drawing/2014/main" id="{F8E6D83D-B809-41FE-B122-105966BE3994}"/>
+                <a16:creationId xmlns:a16="http://schemas.microsoft.com/office/drawing/2014/main" id="{D8FECE75-0D70-4ACF-B501-1F8028D09B6B}"/>
               </a:ext>
             </a:extLst>
           </p:cNvPr>
@@ -3574,7 +3596,7 @@
     </p:spTree>
     <p:extLst>
       <p:ext uri="{BB962C8B-B14F-4D97-AF65-F5344CB8AC3E}">
-        <p14:creationId xmlns:p14="http://schemas.microsoft.com/office/powerpoint/2010/main" val="2029282465"/>
+        <p14:creationId xmlns:p14="http://schemas.microsoft.com/office/powerpoint/2010/main" val="1832284984"/>
       </p:ext>
     </p:extLst>
   </p:cSld>
@@ -3609,7 +3631,7 @@
           <p:nvPr/>
         </p:nvPicPr>
         <p:blipFill>
-          <a:blip xmlns:r="http://schemas.openxmlformats.org/officeDocument/2006/relationships" xmlns:a="http://schemas.openxmlformats.org/drawingml/2006/main" r:embed="R0f935e30b41e45e1"/>
+          <a:blip xmlns:r="http://schemas.openxmlformats.org/officeDocument/2006/relationships" xmlns:a="http://schemas.openxmlformats.org/drawingml/2006/main" r:embed="Rbefcf475730540f5"/>
           <a:stretch xmlns:a="http://schemas.openxmlformats.org/drawingml/2006/main"/>
         </p:blipFill>
         <p:spPr>
@@ -3627,7 +3649,7 @@
           <p:cNvPr id="2" name="">
             <a:extLst xmlns:a="http://schemas.openxmlformats.org/drawingml/2006/main">
               <a:ext uri="{FF2B5EF4-FFF2-40B4-BE49-F238E27FC236}">
-                <a16:creationId xmlns:a16="http://schemas.microsoft.com/office/drawing/2014/main" id="{63810E35-804A-4888-B66A-DFAEE28C6631}"/>
+                <a16:creationId xmlns:a16="http://schemas.microsoft.com/office/drawing/2014/main" id="{1276D8DD-A57C-4A2C-92C5-64E1612F5F1C}"/>
               </a:ext>
             </a:extLst>
           </p:cNvPr>
@@ -3685,7 +3707,7 @@
           <p:cNvPr id="3" name="">
             <a:extLst xmlns:a="http://schemas.openxmlformats.org/drawingml/2006/main">
               <a:ext uri="{FF2B5EF4-FFF2-40B4-BE49-F238E27FC236}">
-                <a16:creationId xmlns:a16="http://schemas.microsoft.com/office/drawing/2014/main" id="{A9A90EAE-F899-4E89-B5F2-DB92563CAF70}"/>
+                <a16:creationId xmlns:a16="http://schemas.microsoft.com/office/drawing/2014/main" id="{0837C06C-5062-42E1-882D-50176ADCF423}"/>
               </a:ext>
             </a:extLst>
           </p:cNvPr>
@@ -3743,7 +3765,7 @@
           <p:cNvPr id="4" name="">
             <a:extLst xmlns:a="http://schemas.openxmlformats.org/drawingml/2006/main">
               <a:ext uri="{FF2B5EF4-FFF2-40B4-BE49-F238E27FC236}">
-                <a16:creationId xmlns:a16="http://schemas.microsoft.com/office/drawing/2014/main" id="{21361E07-4CED-4360-9E78-4AAF034C80F8}"/>
+                <a16:creationId xmlns:a16="http://schemas.microsoft.com/office/drawing/2014/main" id="{30084E57-14D0-4EB2-925F-E11D2E71A0E8}"/>
               </a:ext>
             </a:extLst>
           </p:cNvPr>
@@ -3801,7 +3823,7 @@
           <p:cNvPr id="5" name="">
             <a:extLst xmlns:a="http://schemas.openxmlformats.org/drawingml/2006/main">
               <a:ext uri="{FF2B5EF4-FFF2-40B4-BE49-F238E27FC236}">
-                <a16:creationId xmlns:a16="http://schemas.microsoft.com/office/drawing/2014/main" id="{3829334A-C1F9-49A5-9E81-E4C4A30B7962}"/>
+                <a16:creationId xmlns:a16="http://schemas.microsoft.com/office/drawing/2014/main" id="{8D6D59A3-F142-4EA2-BE58-86E0D7DE4CEC}"/>
               </a:ext>
             </a:extLst>
           </p:cNvPr>
@@ -3859,7 +3881,7 @@
           <p:cNvPr id="6" name="">
             <a:extLst xmlns:a="http://schemas.openxmlformats.org/drawingml/2006/main">
               <a:ext uri="{FF2B5EF4-FFF2-40B4-BE49-F238E27FC236}">
-                <a16:creationId xmlns:a16="http://schemas.microsoft.com/office/drawing/2014/main" id="{CA43D1FF-23ED-4A5E-BDE1-1333297AC056}"/>
+                <a16:creationId xmlns:a16="http://schemas.microsoft.com/office/drawing/2014/main" id="{AC64A34B-61F3-4D6F-9A05-3B96E6BC8F25}"/>
               </a:ext>
             </a:extLst>
           </p:cNvPr>
@@ -3917,7 +3939,7 @@
           <p:cNvPr id="7" name="">
             <a:extLst xmlns:a="http://schemas.openxmlformats.org/drawingml/2006/main">
               <a:ext uri="{FF2B5EF4-FFF2-40B4-BE49-F238E27FC236}">
-                <a16:creationId xmlns:a16="http://schemas.microsoft.com/office/drawing/2014/main" id="{45429A54-60BB-4BF9-870D-7250E7DB7025}"/>
+                <a16:creationId xmlns:a16="http://schemas.microsoft.com/office/drawing/2014/main" id="{9C1E057D-54C7-4EA9-AE06-4BAFB7A4C4FC}"/>
               </a:ext>
             </a:extLst>
           </p:cNvPr>
@@ -3952,7 +3974,7 @@
           <p:cNvPr id="8" name="">
             <a:extLst xmlns:a="http://schemas.openxmlformats.org/drawingml/2006/main">
               <a:ext uri="{FF2B5EF4-FFF2-40B4-BE49-F238E27FC236}">
-                <a16:creationId xmlns:a16="http://schemas.microsoft.com/office/drawing/2014/main" id="{F246A7DF-4E76-4EAB-AB92-6440E271D2F8}"/>
+                <a16:creationId xmlns:a16="http://schemas.microsoft.com/office/drawing/2014/main" id="{34222F5F-9E24-4919-8DEC-AB2C12DA158F}"/>
               </a:ext>
             </a:extLst>
           </p:cNvPr>
@@ -4010,7 +4032,7 @@
           <p:cNvPr id="9" name="">
             <a:extLst xmlns:a="http://schemas.openxmlformats.org/drawingml/2006/main">
               <a:ext uri="{FF2B5EF4-FFF2-40B4-BE49-F238E27FC236}">
-                <a16:creationId xmlns:a16="http://schemas.microsoft.com/office/drawing/2014/main" id="{5113984E-7C85-4236-A629-9B69E5453B52}"/>
+                <a16:creationId xmlns:a16="http://schemas.microsoft.com/office/drawing/2014/main" id="{87872678-955F-419D-85A6-5851E161CBFA}"/>
               </a:ext>
             </a:extLst>
           </p:cNvPr>
@@ -4045,7 +4067,7 @@
           <p:cNvPr id="10" name="">
             <a:extLst xmlns:a="http://schemas.openxmlformats.org/drawingml/2006/main">
               <a:ext uri="{FF2B5EF4-FFF2-40B4-BE49-F238E27FC236}">
-                <a16:creationId xmlns:a16="http://schemas.microsoft.com/office/drawing/2014/main" id="{4EBC41DF-2BCF-460C-8207-498EE013E229}"/>
+                <a16:creationId xmlns:a16="http://schemas.microsoft.com/office/drawing/2014/main" id="{F2D5B3E6-9450-470B-8C3A-547230F69CFD}"/>
               </a:ext>
             </a:extLst>
           </p:cNvPr>
@@ -4103,7 +4125,7 @@
           <p:cNvPr id="11" name="">
             <a:extLst xmlns:a="http://schemas.openxmlformats.org/drawingml/2006/main">
               <a:ext uri="{FF2B5EF4-FFF2-40B4-BE49-F238E27FC236}">
-                <a16:creationId xmlns:a16="http://schemas.microsoft.com/office/drawing/2014/main" id="{B778080B-F416-4680-A504-93FEBB2763B6}"/>
+                <a16:creationId xmlns:a16="http://schemas.microsoft.com/office/drawing/2014/main" id="{80E8EFFB-2E3A-4507-93FA-4073B66AFBF4}"/>
               </a:ext>
             </a:extLst>
           </p:cNvPr>
@@ -4161,7 +4183,7 @@
           <p:cNvPr id="12" name="">
             <a:extLst xmlns:a="http://schemas.openxmlformats.org/drawingml/2006/main">
               <a:ext uri="{FF2B5EF4-FFF2-40B4-BE49-F238E27FC236}">
-                <a16:creationId xmlns:a16="http://schemas.microsoft.com/office/drawing/2014/main" id="{287CCC26-50E6-4EC1-A1AB-D5C607511F1D}"/>
+                <a16:creationId xmlns:a16="http://schemas.microsoft.com/office/drawing/2014/main" id="{0A9DA851-2D40-4722-B5A0-0A7DD3E33D64}"/>
               </a:ext>
             </a:extLst>
           </p:cNvPr>
@@ -4219,7 +4241,7 @@
           <p:cNvPr id="13" name="">
             <a:extLst xmlns:a="http://schemas.openxmlformats.org/drawingml/2006/main">
               <a:ext uri="{FF2B5EF4-FFF2-40B4-BE49-F238E27FC236}">
-                <a16:creationId xmlns:a16="http://schemas.microsoft.com/office/drawing/2014/main" id="{4FC212C6-95E8-4C81-B481-18EF11BBA520}"/>
+                <a16:creationId xmlns:a16="http://schemas.microsoft.com/office/drawing/2014/main" id="{A7DDF367-5991-4693-A552-3465B47AA72A}"/>
               </a:ext>
             </a:extLst>
           </p:cNvPr>
@@ -4277,7 +4299,7 @@
           <p:cNvPr id="14" name="">
             <a:extLst xmlns:a="http://schemas.openxmlformats.org/drawingml/2006/main">
               <a:ext uri="{FF2B5EF4-FFF2-40B4-BE49-F238E27FC236}">
-                <a16:creationId xmlns:a16="http://schemas.microsoft.com/office/drawing/2014/main" id="{488641B9-5AC1-4A5F-A9F0-32A3BB058990}"/>
+                <a16:creationId xmlns:a16="http://schemas.microsoft.com/office/drawing/2014/main" id="{DCA4AAB3-52FF-411F-B4E8-FCE0459337C5}"/>
               </a:ext>
             </a:extLst>
           </p:cNvPr>
@@ -4308,7 +4330,7 @@
           <p:cNvPr id="15" name="">
             <a:extLst xmlns:a="http://schemas.openxmlformats.org/drawingml/2006/main">
               <a:ext uri="{FF2B5EF4-FFF2-40B4-BE49-F238E27FC236}">
-                <a16:creationId xmlns:a16="http://schemas.microsoft.com/office/drawing/2014/main" id="{BFD66E91-1BD1-4591-9823-9E2A1D5CD525}"/>
+                <a16:creationId xmlns:a16="http://schemas.microsoft.com/office/drawing/2014/main" id="{6CF37D52-57AB-4629-A9DA-9BCE5237B0CC}"/>
               </a:ext>
             </a:extLst>
           </p:cNvPr>
@@ -4366,7 +4388,7 @@
           <p:cNvPr id="16" name="">
             <a:extLst xmlns:a="http://schemas.openxmlformats.org/drawingml/2006/main">
               <a:ext uri="{FF2B5EF4-FFF2-40B4-BE49-F238E27FC236}">
-                <a16:creationId xmlns:a16="http://schemas.microsoft.com/office/drawing/2014/main" id="{F9B7B0D8-3ADC-40C4-A896-C24B790D5825}"/>
+                <a16:creationId xmlns:a16="http://schemas.microsoft.com/office/drawing/2014/main" id="{3FF7B067-7979-4B84-B015-4CC701C89B45}"/>
               </a:ext>
             </a:extLst>
           </p:cNvPr>
@@ -4424,7 +4446,7 @@
           <p:cNvPr id="17" name="">
             <a:extLst xmlns:a="http://schemas.openxmlformats.org/drawingml/2006/main">
               <a:ext uri="{FF2B5EF4-FFF2-40B4-BE49-F238E27FC236}">
-                <a16:creationId xmlns:a16="http://schemas.microsoft.com/office/drawing/2014/main" id="{C7D22F2C-A6E0-46E3-A17F-29FB97D4F0A6}"/>
+                <a16:creationId xmlns:a16="http://schemas.microsoft.com/office/drawing/2014/main" id="{E46B25D3-901E-4718-9E5A-6F5A39E4CDF3}"/>
               </a:ext>
             </a:extLst>
           </p:cNvPr>
@@ -4455,7 +4477,7 @@
           <p:cNvPr id="18" name="">
             <a:extLst xmlns:a="http://schemas.openxmlformats.org/drawingml/2006/main">
               <a:ext uri="{FF2B5EF4-FFF2-40B4-BE49-F238E27FC236}">
-                <a16:creationId xmlns:a16="http://schemas.microsoft.com/office/drawing/2014/main" id="{D0C509DA-32AC-49E1-A87B-BF9C8E42DA21}"/>
+                <a16:creationId xmlns:a16="http://schemas.microsoft.com/office/drawing/2014/main" id="{9B9A09A8-47E5-44F8-98A8-5D45194D37C7}"/>
               </a:ext>
             </a:extLst>
           </p:cNvPr>
@@ -4513,7 +4535,7 @@
           <p:cNvPr id="19" name="">
             <a:extLst xmlns:a="http://schemas.openxmlformats.org/drawingml/2006/main">
               <a:ext uri="{FF2B5EF4-FFF2-40B4-BE49-F238E27FC236}">
-                <a16:creationId xmlns:a16="http://schemas.microsoft.com/office/drawing/2014/main" id="{AC7E2598-53A7-49F6-A600-FCA6E84B7BA7}"/>
+                <a16:creationId xmlns:a16="http://schemas.microsoft.com/office/drawing/2014/main" id="{E69A9D1B-FD9D-4AD1-B0A4-0BDCBBCCE375}"/>
               </a:ext>
             </a:extLst>
           </p:cNvPr>
@@ -4571,7 +4593,7 @@
           <p:cNvPr id="20" name="">
             <a:extLst xmlns:a="http://schemas.openxmlformats.org/drawingml/2006/main">
               <a:ext uri="{FF2B5EF4-FFF2-40B4-BE49-F238E27FC236}">
-                <a16:creationId xmlns:a16="http://schemas.microsoft.com/office/drawing/2014/main" id="{377462A0-F337-4DA9-A82C-582A61E459E4}"/>
+                <a16:creationId xmlns:a16="http://schemas.microsoft.com/office/drawing/2014/main" id="{E39A9C52-0B34-4B8E-B71C-FD549CC39633}"/>
               </a:ext>
             </a:extLst>
           </p:cNvPr>
@@ -4602,7 +4624,7 @@
           <p:cNvPr id="21" name="">
             <a:extLst xmlns:a="http://schemas.openxmlformats.org/drawingml/2006/main">
               <a:ext uri="{FF2B5EF4-FFF2-40B4-BE49-F238E27FC236}">
-                <a16:creationId xmlns:a16="http://schemas.microsoft.com/office/drawing/2014/main" id="{638F6711-1BA9-469B-9B5D-3C996D81D199}"/>
+                <a16:creationId xmlns:a16="http://schemas.microsoft.com/office/drawing/2014/main" id="{909719C6-A49D-46A9-970B-9A2DC53AB46F}"/>
               </a:ext>
             </a:extLst>
           </p:cNvPr>
@@ -4660,7 +4682,7 @@
           <p:cNvPr id="22" name="">
             <a:extLst xmlns:a="http://schemas.openxmlformats.org/drawingml/2006/main">
               <a:ext uri="{FF2B5EF4-FFF2-40B4-BE49-F238E27FC236}">
-                <a16:creationId xmlns:a16="http://schemas.microsoft.com/office/drawing/2014/main" id="{941644EA-3395-4166-9898-BBA9B10D366B}"/>
+                <a16:creationId xmlns:a16="http://schemas.microsoft.com/office/drawing/2014/main" id="{FFB8D1FF-3C2C-48F6-ACA9-17933D60E638}"/>
               </a:ext>
             </a:extLst>
           </p:cNvPr>
@@ -4718,7 +4740,7 @@
           <p:cNvPr id="23" name="">
             <a:extLst xmlns:a="http://schemas.openxmlformats.org/drawingml/2006/main">
               <a:ext uri="{FF2B5EF4-FFF2-40B4-BE49-F238E27FC236}">
-                <a16:creationId xmlns:a16="http://schemas.microsoft.com/office/drawing/2014/main" id="{305926F9-ED2F-4BBE-8479-C4C251C7EF5D}"/>
+                <a16:creationId xmlns:a16="http://schemas.microsoft.com/office/drawing/2014/main" id="{60E0E152-4A23-4B5D-BE9F-7FDF5C6567EF}"/>
               </a:ext>
             </a:extLst>
           </p:cNvPr>
@@ -4751,7 +4773,7 @@
           <p:cNvPr id="24" name="">
             <a:extLst xmlns:a="http://schemas.openxmlformats.org/drawingml/2006/main">
               <a:ext uri="{FF2B5EF4-FFF2-40B4-BE49-F238E27FC236}">
-                <a16:creationId xmlns:a16="http://schemas.microsoft.com/office/drawing/2014/main" id="{C6CE0777-BD6E-4F3A-AA17-85687FEB035A}"/>
+                <a16:creationId xmlns:a16="http://schemas.microsoft.com/office/drawing/2014/main" id="{5E0C4745-136D-4500-8648-AA087C40BEDE}"/>
               </a:ext>
             </a:extLst>
           </p:cNvPr>
@@ -4809,7 +4831,7 @@
           <p:cNvPr id="25" name="">
             <a:extLst xmlns:a="http://schemas.openxmlformats.org/drawingml/2006/main">
               <a:ext uri="{FF2B5EF4-FFF2-40B4-BE49-F238E27FC236}">
-                <a16:creationId xmlns:a16="http://schemas.microsoft.com/office/drawing/2014/main" id="{EB96764E-C9CF-403A-A5BC-B06CA9E8821A}"/>
+                <a16:creationId xmlns:a16="http://schemas.microsoft.com/office/drawing/2014/main" id="{BB814FA1-6A7F-4978-8322-F53657A3D306}"/>
               </a:ext>
             </a:extLst>
           </p:cNvPr>
@@ -4865,7 +4887,7 @@
     </p:spTree>
     <p:extLst>
       <p:ext uri="{BB962C8B-B14F-4D97-AF65-F5344CB8AC3E}">
-        <p14:creationId xmlns:p14="http://schemas.microsoft.com/office/powerpoint/2010/main" val="1022452597"/>
+        <p14:creationId xmlns:p14="http://schemas.microsoft.com/office/powerpoint/2010/main" val="1523959524"/>
       </p:ext>
     </p:extLst>
   </p:cSld>
@@ -4900,7 +4922,7 @@
           <p:nvPr/>
         </p:nvPicPr>
         <p:blipFill>
-          <a:blip xmlns:r="http://schemas.openxmlformats.org/officeDocument/2006/relationships" xmlns:a="http://schemas.openxmlformats.org/drawingml/2006/main" r:embed="Rc63d2ac21db64387"/>
+          <a:blip xmlns:r="http://schemas.openxmlformats.org/officeDocument/2006/relationships" xmlns:a="http://schemas.openxmlformats.org/drawingml/2006/main" r:embed="R76001fa70bbb41fa"/>
           <a:stretch xmlns:a="http://schemas.openxmlformats.org/drawingml/2006/main"/>
         </p:blipFill>
         <p:spPr>
@@ -4918,7 +4940,7 @@
           <p:cNvPr id="2" name="">
             <a:extLst xmlns:a="http://schemas.openxmlformats.org/drawingml/2006/main">
               <a:ext uri="{FF2B5EF4-FFF2-40B4-BE49-F238E27FC236}">
-                <a16:creationId xmlns:a16="http://schemas.microsoft.com/office/drawing/2014/main" id="{0E1040EB-B33E-4A25-BEEE-BE80057CCF9C}"/>
+                <a16:creationId xmlns:a16="http://schemas.microsoft.com/office/drawing/2014/main" id="{CBE6192E-368C-46B0-9EA0-5D5244932187}"/>
               </a:ext>
             </a:extLst>
           </p:cNvPr>
@@ -4976,7 +4998,7 @@
           <p:cNvPr id="3" name="">
             <a:extLst xmlns:a="http://schemas.openxmlformats.org/drawingml/2006/main">
               <a:ext uri="{FF2B5EF4-FFF2-40B4-BE49-F238E27FC236}">
-                <a16:creationId xmlns:a16="http://schemas.microsoft.com/office/drawing/2014/main" id="{F84C0134-7EEF-4273-9BDA-EBDB27C31D7C}"/>
+                <a16:creationId xmlns:a16="http://schemas.microsoft.com/office/drawing/2014/main" id="{18AB7882-03C2-4D10-8237-2AA40C4E655A}"/>
               </a:ext>
             </a:extLst>
           </p:cNvPr>
@@ -5034,7 +5056,7 @@
           <p:cNvPr id="4" name="">
             <a:extLst xmlns:a="http://schemas.openxmlformats.org/drawingml/2006/main">
               <a:ext uri="{FF2B5EF4-FFF2-40B4-BE49-F238E27FC236}">
-                <a16:creationId xmlns:a16="http://schemas.microsoft.com/office/drawing/2014/main" id="{28E38E98-7E44-4052-892F-351987324944}"/>
+                <a16:creationId xmlns:a16="http://schemas.microsoft.com/office/drawing/2014/main" id="{E4DFE243-EAA7-4438-B76B-E6985E5F4100}"/>
               </a:ext>
             </a:extLst>
           </p:cNvPr>
@@ -5092,7 +5114,7 @@
           <p:cNvPr id="5" name="">
             <a:extLst xmlns:a="http://schemas.openxmlformats.org/drawingml/2006/main">
               <a:ext uri="{FF2B5EF4-FFF2-40B4-BE49-F238E27FC236}">
-                <a16:creationId xmlns:a16="http://schemas.microsoft.com/office/drawing/2014/main" id="{19D55777-9EC1-401B-98AE-9F9DFAEB5A2B}"/>
+                <a16:creationId xmlns:a16="http://schemas.microsoft.com/office/drawing/2014/main" id="{195EA580-C264-4798-8083-83DECD196BB2}"/>
               </a:ext>
             </a:extLst>
           </p:cNvPr>
@@ -5150,7 +5172,7 @@
           <p:cNvPr id="6" name="">
             <a:extLst xmlns:a="http://schemas.openxmlformats.org/drawingml/2006/main">
               <a:ext uri="{FF2B5EF4-FFF2-40B4-BE49-F238E27FC236}">
-                <a16:creationId xmlns:a16="http://schemas.microsoft.com/office/drawing/2014/main" id="{DC9BBBE8-D4F5-4DDF-AEAC-2B52B1E9092D}"/>
+                <a16:creationId xmlns:a16="http://schemas.microsoft.com/office/drawing/2014/main" id="{4E4631EE-8087-41EB-8020-72CE1B9758AF}"/>
               </a:ext>
             </a:extLst>
           </p:cNvPr>
@@ -5208,7 +5230,7 @@
           <p:cNvPr id="7" name="">
             <a:extLst xmlns:a="http://schemas.openxmlformats.org/drawingml/2006/main">
               <a:ext uri="{FF2B5EF4-FFF2-40B4-BE49-F238E27FC236}">
-                <a16:creationId xmlns:a16="http://schemas.microsoft.com/office/drawing/2014/main" id="{D7B57B43-F55B-4CB1-9F67-10FB46460F09}"/>
+                <a16:creationId xmlns:a16="http://schemas.microsoft.com/office/drawing/2014/main" id="{DB1376F9-C692-47B4-81B7-EEEB1EC8EE88}"/>
               </a:ext>
             </a:extLst>
           </p:cNvPr>
@@ -5239,7 +5261,7 @@
           <p:cNvPr id="8" name="">
             <a:extLst xmlns:a="http://schemas.openxmlformats.org/drawingml/2006/main">
               <a:ext uri="{FF2B5EF4-FFF2-40B4-BE49-F238E27FC236}">
-                <a16:creationId xmlns:a16="http://schemas.microsoft.com/office/drawing/2014/main" id="{1E78BF7D-D0DD-42D2-9DCE-D4490922A668}"/>
+                <a16:creationId xmlns:a16="http://schemas.microsoft.com/office/drawing/2014/main" id="{2A844E09-8CBB-457C-8BD4-F1EE3AF6D793}"/>
               </a:ext>
             </a:extLst>
           </p:cNvPr>
@@ -5270,7 +5292,7 @@
           <p:cNvPr id="9" name="">
             <a:extLst xmlns:a="http://schemas.openxmlformats.org/drawingml/2006/main">
               <a:ext uri="{FF2B5EF4-FFF2-40B4-BE49-F238E27FC236}">
-                <a16:creationId xmlns:a16="http://schemas.microsoft.com/office/drawing/2014/main" id="{5B2F909D-BCFA-44A7-B578-DCC7E30025C1}"/>
+                <a16:creationId xmlns:a16="http://schemas.microsoft.com/office/drawing/2014/main" id="{0760507B-05B6-4638-9062-333B7616F38B}"/>
               </a:ext>
             </a:extLst>
           </p:cNvPr>
@@ -5301,7 +5323,7 @@
           <p:cNvPr id="10" name="">
             <a:extLst xmlns:a="http://schemas.openxmlformats.org/drawingml/2006/main">
               <a:ext uri="{FF2B5EF4-FFF2-40B4-BE49-F238E27FC236}">
-                <a16:creationId xmlns:a16="http://schemas.microsoft.com/office/drawing/2014/main" id="{852ED1AD-89D5-4FE3-AD02-BE58A592C5E8}"/>
+                <a16:creationId xmlns:a16="http://schemas.microsoft.com/office/drawing/2014/main" id="{A24D468A-F3A7-4714-BB4A-EB0D8BC586D1}"/>
               </a:ext>
             </a:extLst>
           </p:cNvPr>
@@ -5332,7 +5354,7 @@
           <p:cNvPr id="11" name="">
             <a:extLst xmlns:a="http://schemas.openxmlformats.org/drawingml/2006/main">
               <a:ext uri="{FF2B5EF4-FFF2-40B4-BE49-F238E27FC236}">
-                <a16:creationId xmlns:a16="http://schemas.microsoft.com/office/drawing/2014/main" id="{D44DF9D3-6727-47E5-989D-8EE931009F7C}"/>
+                <a16:creationId xmlns:a16="http://schemas.microsoft.com/office/drawing/2014/main" id="{59E805F3-18AD-455B-92BC-ABB05D122503}"/>
               </a:ext>
             </a:extLst>
           </p:cNvPr>
@@ -5363,7 +5385,7 @@
           <p:cNvPr id="12" name="">
             <a:extLst xmlns:a="http://schemas.openxmlformats.org/drawingml/2006/main">
               <a:ext uri="{FF2B5EF4-FFF2-40B4-BE49-F238E27FC236}">
-                <a16:creationId xmlns:a16="http://schemas.microsoft.com/office/drawing/2014/main" id="{46336ABE-B499-4E95-88ED-02E7EAC8FD82}"/>
+                <a16:creationId xmlns:a16="http://schemas.microsoft.com/office/drawing/2014/main" id="{470858A7-8964-4945-8E66-368E81421215}"/>
               </a:ext>
             </a:extLst>
           </p:cNvPr>
@@ -5398,7 +5420,7 @@
           <p:cNvPr id="13" name="">
             <a:extLst xmlns:a="http://schemas.openxmlformats.org/drawingml/2006/main">
               <a:ext uri="{FF2B5EF4-FFF2-40B4-BE49-F238E27FC236}">
-                <a16:creationId xmlns:a16="http://schemas.microsoft.com/office/drawing/2014/main" id="{733C0A81-6548-49A2-B1BF-4635FE9AC0AC}"/>
+                <a16:creationId xmlns:a16="http://schemas.microsoft.com/office/drawing/2014/main" id="{71F3F11F-B31E-44BA-AA60-E540BCD5B432}"/>
               </a:ext>
             </a:extLst>
           </p:cNvPr>
@@ -5456,7 +5478,7 @@
           <p:cNvPr id="14" name="">
             <a:extLst xmlns:a="http://schemas.openxmlformats.org/drawingml/2006/main">
               <a:ext uri="{FF2B5EF4-FFF2-40B4-BE49-F238E27FC236}">
-                <a16:creationId xmlns:a16="http://schemas.microsoft.com/office/drawing/2014/main" id="{D4672B9B-3053-4B27-9F1C-443E7E07CF15}"/>
+                <a16:creationId xmlns:a16="http://schemas.microsoft.com/office/drawing/2014/main" id="{81D5B339-B561-41C0-A226-1DA15D227A6D}"/>
               </a:ext>
             </a:extLst>
           </p:cNvPr>
@@ -5514,7 +5536,7 @@
           <p:cNvPr id="15" name="">
             <a:extLst xmlns:a="http://schemas.openxmlformats.org/drawingml/2006/main">
               <a:ext uri="{FF2B5EF4-FFF2-40B4-BE49-F238E27FC236}">
-                <a16:creationId xmlns:a16="http://schemas.microsoft.com/office/drawing/2014/main" id="{D7A1381E-9152-4FCB-B6BE-D4412E44E545}"/>
+                <a16:creationId xmlns:a16="http://schemas.microsoft.com/office/drawing/2014/main" id="{53F6806E-BAB0-46B9-8375-9FD8808E64A4}"/>
               </a:ext>
             </a:extLst>
           </p:cNvPr>
@@ -5572,7 +5594,7 @@
           <p:cNvPr id="16" name="">
             <a:extLst xmlns:a="http://schemas.openxmlformats.org/drawingml/2006/main">
               <a:ext uri="{FF2B5EF4-FFF2-40B4-BE49-F238E27FC236}">
-                <a16:creationId xmlns:a16="http://schemas.microsoft.com/office/drawing/2014/main" id="{053A8D8D-0F6B-4C9D-87F7-92E1DFA66462}"/>
+                <a16:creationId xmlns:a16="http://schemas.microsoft.com/office/drawing/2014/main" id="{DE88763A-F73B-44B3-A056-F02C85E0EE9E}"/>
               </a:ext>
             </a:extLst>
           </p:cNvPr>
@@ -5607,7 +5629,7 @@
           <p:cNvPr id="17" name="">
             <a:extLst xmlns:a="http://schemas.openxmlformats.org/drawingml/2006/main">
               <a:ext uri="{FF2B5EF4-FFF2-40B4-BE49-F238E27FC236}">
-                <a16:creationId xmlns:a16="http://schemas.microsoft.com/office/drawing/2014/main" id="{D40B3CA8-02BA-4C39-BB05-B28F44D12D1B}"/>
+                <a16:creationId xmlns:a16="http://schemas.microsoft.com/office/drawing/2014/main" id="{3769C0D5-4A1A-4361-BC11-59C242E483C9}"/>
               </a:ext>
             </a:extLst>
           </p:cNvPr>
@@ -5665,7 +5687,7 @@
           <p:cNvPr id="18" name="">
             <a:extLst xmlns:a="http://schemas.openxmlformats.org/drawingml/2006/main">
               <a:ext uri="{FF2B5EF4-FFF2-40B4-BE49-F238E27FC236}">
-                <a16:creationId xmlns:a16="http://schemas.microsoft.com/office/drawing/2014/main" id="{C0A217FC-BE00-496A-B00F-953FE2A16406}"/>
+                <a16:creationId xmlns:a16="http://schemas.microsoft.com/office/drawing/2014/main" id="{1C77EA7F-8577-498D-BDD9-192D40CFB187}"/>
               </a:ext>
             </a:extLst>
           </p:cNvPr>
@@ -5723,7 +5745,7 @@
           <p:cNvPr id="19" name="">
             <a:extLst xmlns:a="http://schemas.openxmlformats.org/drawingml/2006/main">
               <a:ext uri="{FF2B5EF4-FFF2-40B4-BE49-F238E27FC236}">
-                <a16:creationId xmlns:a16="http://schemas.microsoft.com/office/drawing/2014/main" id="{38BE985D-0A21-402A-A850-1A40B989CFC9}"/>
+                <a16:creationId xmlns:a16="http://schemas.microsoft.com/office/drawing/2014/main" id="{33377889-50EA-4DE0-B71E-49D4AE7CA6CF}"/>
               </a:ext>
             </a:extLst>
           </p:cNvPr>
@@ -5781,7 +5803,7 @@
           <p:cNvPr id="20" name="">
             <a:extLst xmlns:a="http://schemas.openxmlformats.org/drawingml/2006/main">
               <a:ext uri="{FF2B5EF4-FFF2-40B4-BE49-F238E27FC236}">
-                <a16:creationId xmlns:a16="http://schemas.microsoft.com/office/drawing/2014/main" id="{CA0ACFBC-5A06-45D1-A6AC-A6623DC28FF6}"/>
+                <a16:creationId xmlns:a16="http://schemas.microsoft.com/office/drawing/2014/main" id="{33A7F124-495D-4073-9D3A-D16BAA78A72A}"/>
               </a:ext>
             </a:extLst>
           </p:cNvPr>
@@ -5816,7 +5838,7 @@
           <p:cNvPr id="21" name="">
             <a:extLst xmlns:a="http://schemas.openxmlformats.org/drawingml/2006/main">
               <a:ext uri="{FF2B5EF4-FFF2-40B4-BE49-F238E27FC236}">
-                <a16:creationId xmlns:a16="http://schemas.microsoft.com/office/drawing/2014/main" id="{96E2BC86-11BC-4290-B57A-111FCBA7D890}"/>
+                <a16:creationId xmlns:a16="http://schemas.microsoft.com/office/drawing/2014/main" id="{45047C45-1179-48A8-93F8-C2DD5153F6FF}"/>
               </a:ext>
             </a:extLst>
           </p:cNvPr>
@@ -5874,7 +5896,7 @@
           <p:cNvPr id="22" name="">
             <a:extLst xmlns:a="http://schemas.openxmlformats.org/drawingml/2006/main">
               <a:ext uri="{FF2B5EF4-FFF2-40B4-BE49-F238E27FC236}">
-                <a16:creationId xmlns:a16="http://schemas.microsoft.com/office/drawing/2014/main" id="{FDBB0D69-0B61-42DD-8342-6617A854D734}"/>
+                <a16:creationId xmlns:a16="http://schemas.microsoft.com/office/drawing/2014/main" id="{27E5A001-15BF-4A59-AF99-8DCFC40D290D}"/>
               </a:ext>
             </a:extLst>
           </p:cNvPr>
@@ -5932,7 +5954,7 @@
           <p:cNvPr id="23" name="">
             <a:extLst xmlns:a="http://schemas.openxmlformats.org/drawingml/2006/main">
               <a:ext uri="{FF2B5EF4-FFF2-40B4-BE49-F238E27FC236}">
-                <a16:creationId xmlns:a16="http://schemas.microsoft.com/office/drawing/2014/main" id="{4EF01697-9D43-43A5-92E8-AC7C93A5997A}"/>
+                <a16:creationId xmlns:a16="http://schemas.microsoft.com/office/drawing/2014/main" id="{3F7036F6-EC34-4C43-A63A-C7FB317328F2}"/>
               </a:ext>
             </a:extLst>
           </p:cNvPr>
@@ -5990,7 +6012,7 @@
           <p:cNvPr id="24" name="">
             <a:extLst xmlns:a="http://schemas.openxmlformats.org/drawingml/2006/main">
               <a:ext uri="{FF2B5EF4-FFF2-40B4-BE49-F238E27FC236}">
-                <a16:creationId xmlns:a16="http://schemas.microsoft.com/office/drawing/2014/main" id="{17FF150C-CD28-4506-97D9-54C644DCF2B8}"/>
+                <a16:creationId xmlns:a16="http://schemas.microsoft.com/office/drawing/2014/main" id="{AE5E0B6F-DC76-4711-97FC-772B5720F554}"/>
               </a:ext>
             </a:extLst>
           </p:cNvPr>
@@ -6023,7 +6045,7 @@
           <p:cNvPr id="25" name="">
             <a:extLst xmlns:a="http://schemas.openxmlformats.org/drawingml/2006/main">
               <a:ext uri="{FF2B5EF4-FFF2-40B4-BE49-F238E27FC236}">
-                <a16:creationId xmlns:a16="http://schemas.microsoft.com/office/drawing/2014/main" id="{C90ACA22-5E6A-4F68-9438-D163C1A52C2C}"/>
+                <a16:creationId xmlns:a16="http://schemas.microsoft.com/office/drawing/2014/main" id="{63F06922-33C5-42CA-B016-2CDD3F3D6055}"/>
               </a:ext>
             </a:extLst>
           </p:cNvPr>
@@ -6081,7 +6103,7 @@
           <p:cNvPr id="26" name="">
             <a:extLst xmlns:a="http://schemas.openxmlformats.org/drawingml/2006/main">
               <a:ext uri="{FF2B5EF4-FFF2-40B4-BE49-F238E27FC236}">
-                <a16:creationId xmlns:a16="http://schemas.microsoft.com/office/drawing/2014/main" id="{B626F7AF-C0DD-4B51-98FA-B5C6670220C9}"/>
+                <a16:creationId xmlns:a16="http://schemas.microsoft.com/office/drawing/2014/main" id="{3B372302-C366-43FE-B347-BC05FB85AC38}"/>
               </a:ext>
             </a:extLst>
           </p:cNvPr>
@@ -6116,7 +6138,7 @@
           <p:cNvPr id="27" name="">
             <a:extLst xmlns:a="http://schemas.openxmlformats.org/drawingml/2006/main">
               <a:ext uri="{FF2B5EF4-FFF2-40B4-BE49-F238E27FC236}">
-                <a16:creationId xmlns:a16="http://schemas.microsoft.com/office/drawing/2014/main" id="{441E51BC-3BE0-4FE6-9DEA-ECD1603104CD}"/>
+                <a16:creationId xmlns:a16="http://schemas.microsoft.com/office/drawing/2014/main" id="{2224781D-7422-4B62-9BF5-2D368AE08544}"/>
               </a:ext>
             </a:extLst>
           </p:cNvPr>
@@ -6174,7 +6196,7 @@
           <p:cNvPr id="28" name="">
             <a:extLst xmlns:a="http://schemas.openxmlformats.org/drawingml/2006/main">
               <a:ext uri="{FF2B5EF4-FFF2-40B4-BE49-F238E27FC236}">
-                <a16:creationId xmlns:a16="http://schemas.microsoft.com/office/drawing/2014/main" id="{FCEE0AA8-1F50-41E6-B1B0-8D7DF9EE48C8}"/>
+                <a16:creationId xmlns:a16="http://schemas.microsoft.com/office/drawing/2014/main" id="{BCB63020-622E-41A7-B3C2-2BC450E0B3C0}"/>
               </a:ext>
             </a:extLst>
           </p:cNvPr>
@@ -6232,7 +6254,7 @@
           <p:cNvPr id="29" name="">
             <a:extLst xmlns:a="http://schemas.openxmlformats.org/drawingml/2006/main">
               <a:ext uri="{FF2B5EF4-FFF2-40B4-BE49-F238E27FC236}">
-                <a16:creationId xmlns:a16="http://schemas.microsoft.com/office/drawing/2014/main" id="{FAD85450-72FE-432E-B931-E7899D987860}"/>
+                <a16:creationId xmlns:a16="http://schemas.microsoft.com/office/drawing/2014/main" id="{E260D59D-79E5-4DFE-921F-87F8DCEBAB43}"/>
               </a:ext>
             </a:extLst>
           </p:cNvPr>
@@ -6290,7 +6312,7 @@
           <p:cNvPr id="30" name="">
             <a:extLst xmlns:a="http://schemas.openxmlformats.org/drawingml/2006/main">
               <a:ext uri="{FF2B5EF4-FFF2-40B4-BE49-F238E27FC236}">
-                <a16:creationId xmlns:a16="http://schemas.microsoft.com/office/drawing/2014/main" id="{4FE94532-07BC-4E77-A07C-4471553DFD44}"/>
+                <a16:creationId xmlns:a16="http://schemas.microsoft.com/office/drawing/2014/main" id="{D432F87F-DD77-4A68-BC84-B44FC06B59FB}"/>
               </a:ext>
             </a:extLst>
           </p:cNvPr>
@@ -6325,7 +6347,7 @@
           <p:cNvPr id="31" name="">
             <a:extLst xmlns:a="http://schemas.openxmlformats.org/drawingml/2006/main">
               <a:ext uri="{FF2B5EF4-FFF2-40B4-BE49-F238E27FC236}">
-                <a16:creationId xmlns:a16="http://schemas.microsoft.com/office/drawing/2014/main" id="{A40BE542-C163-441F-8B08-84A3D912923E}"/>
+                <a16:creationId xmlns:a16="http://schemas.microsoft.com/office/drawing/2014/main" id="{6C8CF303-B08B-4ABA-A17D-655B73C8A7D0}"/>
               </a:ext>
             </a:extLst>
           </p:cNvPr>
@@ -6383,7 +6405,7 @@
           <p:cNvPr id="32" name="">
             <a:extLst xmlns:a="http://schemas.openxmlformats.org/drawingml/2006/main">
               <a:ext uri="{FF2B5EF4-FFF2-40B4-BE49-F238E27FC236}">
-                <a16:creationId xmlns:a16="http://schemas.microsoft.com/office/drawing/2014/main" id="{CD11CB4F-BC7A-4B1A-AEC9-C2E8A1E757CB}"/>
+                <a16:creationId xmlns:a16="http://schemas.microsoft.com/office/drawing/2014/main" id="{26132AB6-7DE8-419A-92B5-79718DBAB1CD}"/>
               </a:ext>
             </a:extLst>
           </p:cNvPr>
@@ -6441,7 +6463,7 @@
           <p:cNvPr id="33" name="">
             <a:extLst xmlns:a="http://schemas.openxmlformats.org/drawingml/2006/main">
               <a:ext uri="{FF2B5EF4-FFF2-40B4-BE49-F238E27FC236}">
-                <a16:creationId xmlns:a16="http://schemas.microsoft.com/office/drawing/2014/main" id="{75CE1FAF-F7A6-4AD3-802B-5322CA6FDCFB}"/>
+                <a16:creationId xmlns:a16="http://schemas.microsoft.com/office/drawing/2014/main" id="{EBD902FF-FD2A-45A5-A0D3-ABA34965F82D}"/>
               </a:ext>
             </a:extLst>
           </p:cNvPr>
@@ -6476,7 +6498,7 @@
           <p:cNvPr id="34" name="">
             <a:extLst xmlns:a="http://schemas.openxmlformats.org/drawingml/2006/main">
               <a:ext uri="{FF2B5EF4-FFF2-40B4-BE49-F238E27FC236}">
-                <a16:creationId xmlns:a16="http://schemas.microsoft.com/office/drawing/2014/main" id="{C203F080-C471-4F1B-A9E7-C7E692E522D9}"/>
+                <a16:creationId xmlns:a16="http://schemas.microsoft.com/office/drawing/2014/main" id="{6BCC0B11-8FC5-4781-9D3C-1D0AE97B3F9B}"/>
               </a:ext>
             </a:extLst>
           </p:cNvPr>
@@ -6534,7 +6556,7 @@
           <p:cNvPr id="35" name="">
             <a:extLst xmlns:a="http://schemas.openxmlformats.org/drawingml/2006/main">
               <a:ext uri="{FF2B5EF4-FFF2-40B4-BE49-F238E27FC236}">
-                <a16:creationId xmlns:a16="http://schemas.microsoft.com/office/drawing/2014/main" id="{019DE3AA-935D-49A0-B89E-280582ED2AE2}"/>
+                <a16:creationId xmlns:a16="http://schemas.microsoft.com/office/drawing/2014/main" id="{90DFA677-5267-4E53-BFBB-D9086820D0CA}"/>
               </a:ext>
             </a:extLst>
           </p:cNvPr>
@@ -6592,7 +6614,7 @@
           <p:cNvPr id="36" name="">
             <a:extLst xmlns:a="http://schemas.openxmlformats.org/drawingml/2006/main">
               <a:ext uri="{FF2B5EF4-FFF2-40B4-BE49-F238E27FC236}">
-                <a16:creationId xmlns:a16="http://schemas.microsoft.com/office/drawing/2014/main" id="{6ECFFCCD-18FD-48C1-888F-0FDD096BB608}"/>
+                <a16:creationId xmlns:a16="http://schemas.microsoft.com/office/drawing/2014/main" id="{53E9D88E-F2C6-4D4B-8CAF-D1B9BFBF485D}"/>
               </a:ext>
             </a:extLst>
           </p:cNvPr>
@@ -6639,7 +6661,7 @@
                 <a:latin typeface="Aptos"/>
                 <a:ea typeface="Aptos"/>
                 <a:cs typeface="Aptos"/>
-                <a:hlinkClick xmlns:r="http://schemas.openxmlformats.org/officeDocument/2006/relationships" r:id="Re817ed10cc3a406f"/>
+                <a:hlinkClick xmlns:r="http://schemas.openxmlformats.org/officeDocument/2006/relationships" r:id="Ra6ba141183764eff"/>
               </a:rPr>
               <a:t>Particle activity 0x06567b3a8eed3a</a:t>
             </a:r>
@@ -6651,7 +6673,7 @@
           <p:cNvPr id="37" name="">
             <a:extLst xmlns:a="http://schemas.openxmlformats.org/drawingml/2006/main">
               <a:ext uri="{FF2B5EF4-FFF2-40B4-BE49-F238E27FC236}">
-                <a16:creationId xmlns:a16="http://schemas.microsoft.com/office/drawing/2014/main" id="{8B5E72D3-B869-4734-A6B1-15260E380149}"/>
+                <a16:creationId xmlns:a16="http://schemas.microsoft.com/office/drawing/2014/main" id="{4E47C4DD-7D2A-43EF-9490-46027304C6DB}"/>
               </a:ext>
             </a:extLst>
           </p:cNvPr>
@@ -6707,7 +6729,7 @@
     </p:spTree>
     <p:extLst>
       <p:ext uri="{BB962C8B-B14F-4D97-AF65-F5344CB8AC3E}">
-        <p14:creationId xmlns:p14="http://schemas.microsoft.com/office/powerpoint/2010/main" val="1337649686"/>
+        <p14:creationId xmlns:p14="http://schemas.microsoft.com/office/powerpoint/2010/main" val="702424124"/>
       </p:ext>
     </p:extLst>
   </p:cSld>
@@ -6742,7 +6764,7 @@
           <p:nvPr/>
         </p:nvPicPr>
         <p:blipFill>
-          <a:blip xmlns:r="http://schemas.openxmlformats.org/officeDocument/2006/relationships" xmlns:a="http://schemas.openxmlformats.org/drawingml/2006/main" r:embed="Rf5d92a25e8e5440f"/>
+          <a:blip xmlns:r="http://schemas.openxmlformats.org/officeDocument/2006/relationships" xmlns:a="http://schemas.openxmlformats.org/drawingml/2006/main" r:embed="Rc85434e7a80e4b2c"/>
           <a:stretch xmlns:a="http://schemas.openxmlformats.org/drawingml/2006/main"/>
         </p:blipFill>
         <p:spPr>
@@ -6760,7 +6782,7 @@
           <p:cNvPr id="2" name="">
             <a:extLst xmlns:a="http://schemas.openxmlformats.org/drawingml/2006/main">
               <a:ext uri="{FF2B5EF4-FFF2-40B4-BE49-F238E27FC236}">
-                <a16:creationId xmlns:a16="http://schemas.microsoft.com/office/drawing/2014/main" id="{28B0A76E-1EF0-49F7-AAF1-7990E94F2852}"/>
+                <a16:creationId xmlns:a16="http://schemas.microsoft.com/office/drawing/2014/main" id="{52033879-601B-48BF-9CC1-7C6318A3EC02}"/>
               </a:ext>
             </a:extLst>
           </p:cNvPr>
@@ -6818,7 +6840,7 @@
           <p:cNvPr id="3" name="">
             <a:extLst xmlns:a="http://schemas.openxmlformats.org/drawingml/2006/main">
               <a:ext uri="{FF2B5EF4-FFF2-40B4-BE49-F238E27FC236}">
-                <a16:creationId xmlns:a16="http://schemas.microsoft.com/office/drawing/2014/main" id="{DDB00F47-D828-48F3-9CBE-D34D75FB59A5}"/>
+                <a16:creationId xmlns:a16="http://schemas.microsoft.com/office/drawing/2014/main" id="{53323862-7C57-4DB4-859A-4EC31AF58757}"/>
               </a:ext>
             </a:extLst>
           </p:cNvPr>
@@ -6876,7 +6898,7 @@
           <p:cNvPr id="4" name="">
             <a:extLst xmlns:a="http://schemas.openxmlformats.org/drawingml/2006/main">
               <a:ext uri="{FF2B5EF4-FFF2-40B4-BE49-F238E27FC236}">
-                <a16:creationId xmlns:a16="http://schemas.microsoft.com/office/drawing/2014/main" id="{F42AA3DD-8514-42D8-9AD8-592805CE5694}"/>
+                <a16:creationId xmlns:a16="http://schemas.microsoft.com/office/drawing/2014/main" id="{6DBC22DB-0833-43DD-855A-32AAF8B5F208}"/>
               </a:ext>
             </a:extLst>
           </p:cNvPr>
@@ -6934,7 +6956,7 @@
           <p:cNvPr id="5" name="">
             <a:extLst xmlns:a="http://schemas.openxmlformats.org/drawingml/2006/main">
               <a:ext uri="{FF2B5EF4-FFF2-40B4-BE49-F238E27FC236}">
-                <a16:creationId xmlns:a16="http://schemas.microsoft.com/office/drawing/2014/main" id="{7CEBA231-87D0-4A74-95FD-DA77AED982A1}"/>
+                <a16:creationId xmlns:a16="http://schemas.microsoft.com/office/drawing/2014/main" id="{98AA64CC-0587-4CB7-A11C-707D4D3EAE3A}"/>
               </a:ext>
             </a:extLst>
           </p:cNvPr>
@@ -6992,7 +7014,7 @@
           <p:cNvPr id="6" name="">
             <a:extLst xmlns:a="http://schemas.openxmlformats.org/drawingml/2006/main">
               <a:ext uri="{FF2B5EF4-FFF2-40B4-BE49-F238E27FC236}">
-                <a16:creationId xmlns:a16="http://schemas.microsoft.com/office/drawing/2014/main" id="{5840B1D8-81A3-4953-99B9-A75BBC2885F0}"/>
+                <a16:creationId xmlns:a16="http://schemas.microsoft.com/office/drawing/2014/main" id="{5C7A09B4-A3EB-4590-88F1-E4A0092F9DE9}"/>
               </a:ext>
             </a:extLst>
           </p:cNvPr>
@@ -7050,7 +7072,7 @@
           <p:cNvPr id="7" name="">
             <a:extLst xmlns:a="http://schemas.openxmlformats.org/drawingml/2006/main">
               <a:ext uri="{FF2B5EF4-FFF2-40B4-BE49-F238E27FC236}">
-                <a16:creationId xmlns:a16="http://schemas.microsoft.com/office/drawing/2014/main" id="{3F5767EB-8427-4B0C-B961-D794D99B8409}"/>
+                <a16:creationId xmlns:a16="http://schemas.microsoft.com/office/drawing/2014/main" id="{9DC8793B-0294-43F9-8231-E52B0682DB2E}"/>
               </a:ext>
             </a:extLst>
           </p:cNvPr>
@@ -7089,7 +7111,7 @@
           <p:nvPr/>
         </p:nvPicPr>
         <p:blipFill>
-          <a:blip xmlns:r="http://schemas.openxmlformats.org/officeDocument/2006/relationships" xmlns:a="http://schemas.openxmlformats.org/drawingml/2006/main" r:embed="R537dbdf466de4a5f"/>
+          <a:blip xmlns:r="http://schemas.openxmlformats.org/officeDocument/2006/relationships" xmlns:a="http://schemas.openxmlformats.org/drawingml/2006/main" r:embed="R9ccbb68e63fb4fe7"/>
           <a:srcRect xmlns:a="http://schemas.openxmlformats.org/drawingml/2006/main" l="0" t="4444" r="0" b="4444"/>
           <a:stretch xmlns:a="http://schemas.openxmlformats.org/drawingml/2006/main">
             <a:fillRect l="0" t="0" r="0" b="0"/>
@@ -7112,7 +7134,7 @@
           <p:cNvPr id="9" name="">
             <a:extLst xmlns:a="http://schemas.openxmlformats.org/drawingml/2006/main">
               <a:ext uri="{FF2B5EF4-FFF2-40B4-BE49-F238E27FC236}">
-                <a16:creationId xmlns:a16="http://schemas.microsoft.com/office/drawing/2014/main" id="{51E51468-0613-4426-A05E-8EC2BDCFD9E1}"/>
+                <a16:creationId xmlns:a16="http://schemas.microsoft.com/office/drawing/2014/main" id="{B52BED9E-5474-47FF-8D07-51E90F48C046}"/>
               </a:ext>
             </a:extLst>
           </p:cNvPr>
@@ -7170,7 +7192,7 @@
           <p:cNvPr id="10" name="">
             <a:extLst xmlns:a="http://schemas.openxmlformats.org/drawingml/2006/main">
               <a:ext uri="{FF2B5EF4-FFF2-40B4-BE49-F238E27FC236}">
-                <a16:creationId xmlns:a16="http://schemas.microsoft.com/office/drawing/2014/main" id="{B77F84EE-07C7-428A-9B70-65A6771E9BEA}"/>
+                <a16:creationId xmlns:a16="http://schemas.microsoft.com/office/drawing/2014/main" id="{437A11B1-8F73-4629-8725-EE50215031F0}"/>
               </a:ext>
             </a:extLst>
           </p:cNvPr>
@@ -7201,7 +7223,7 @@
           <p:cNvPr id="11" name="">
             <a:extLst xmlns:a="http://schemas.openxmlformats.org/drawingml/2006/main">
               <a:ext uri="{FF2B5EF4-FFF2-40B4-BE49-F238E27FC236}">
-                <a16:creationId xmlns:a16="http://schemas.microsoft.com/office/drawing/2014/main" id="{6E9A0E7E-3944-4D33-A0BD-6E2C32DDD915}"/>
+                <a16:creationId xmlns:a16="http://schemas.microsoft.com/office/drawing/2014/main" id="{FB90AF2F-7D46-4F21-AC8F-A788FC87F1C3}"/>
               </a:ext>
             </a:extLst>
           </p:cNvPr>
@@ -7259,7 +7281,7 @@
           <p:cNvPr id="12" name="">
             <a:extLst xmlns:a="http://schemas.openxmlformats.org/drawingml/2006/main">
               <a:ext uri="{FF2B5EF4-FFF2-40B4-BE49-F238E27FC236}">
-                <a16:creationId xmlns:a16="http://schemas.microsoft.com/office/drawing/2014/main" id="{02EC262C-B817-42ED-BAA0-4DC804B3312A}"/>
+                <a16:creationId xmlns:a16="http://schemas.microsoft.com/office/drawing/2014/main" id="{3E91F76B-C324-4C0F-88DB-8CE29EC6BAD7}"/>
               </a:ext>
             </a:extLst>
           </p:cNvPr>
@@ -7317,7 +7339,7 @@
           <p:cNvPr id="13" name="">
             <a:extLst xmlns:a="http://schemas.openxmlformats.org/drawingml/2006/main">
               <a:ext uri="{FF2B5EF4-FFF2-40B4-BE49-F238E27FC236}">
-                <a16:creationId xmlns:a16="http://schemas.microsoft.com/office/drawing/2014/main" id="{1E04C1C1-2D53-412E-BBC5-9473389B0175}"/>
+                <a16:creationId xmlns:a16="http://schemas.microsoft.com/office/drawing/2014/main" id="{533E4BB4-90C6-45FD-8D84-5838B89C8847}"/>
               </a:ext>
             </a:extLst>
           </p:cNvPr>
@@ -7348,7 +7370,7 @@
           <p:cNvPr id="14" name="">
             <a:extLst xmlns:a="http://schemas.openxmlformats.org/drawingml/2006/main">
               <a:ext uri="{FF2B5EF4-FFF2-40B4-BE49-F238E27FC236}">
-                <a16:creationId xmlns:a16="http://schemas.microsoft.com/office/drawing/2014/main" id="{2CE97A84-237A-4045-AAFC-3C1A19CC7307}"/>
+                <a16:creationId xmlns:a16="http://schemas.microsoft.com/office/drawing/2014/main" id="{7290E563-22ED-4CAA-8E8E-8A5CCB251DD9}"/>
               </a:ext>
             </a:extLst>
           </p:cNvPr>
@@ -7406,7 +7428,7 @@
           <p:cNvPr id="15" name="">
             <a:extLst xmlns:a="http://schemas.openxmlformats.org/drawingml/2006/main">
               <a:ext uri="{FF2B5EF4-FFF2-40B4-BE49-F238E27FC236}">
-                <a16:creationId xmlns:a16="http://schemas.microsoft.com/office/drawing/2014/main" id="{1F265C85-0ED9-451B-B955-E830DDFEAA92}"/>
+                <a16:creationId xmlns:a16="http://schemas.microsoft.com/office/drawing/2014/main" id="{9ACB6F1D-1EC9-4F2F-B066-69D207ACD39A}"/>
               </a:ext>
             </a:extLst>
           </p:cNvPr>
@@ -7464,7 +7486,7 @@
           <p:cNvPr id="16" name="">
             <a:extLst xmlns:a="http://schemas.openxmlformats.org/drawingml/2006/main">
               <a:ext uri="{FF2B5EF4-FFF2-40B4-BE49-F238E27FC236}">
-                <a16:creationId xmlns:a16="http://schemas.microsoft.com/office/drawing/2014/main" id="{8F530452-AB9E-4D20-BD33-F3434A02F9F2}"/>
+                <a16:creationId xmlns:a16="http://schemas.microsoft.com/office/drawing/2014/main" id="{8A1896FD-3FD6-4803-BC00-07117EC63EDE}"/>
               </a:ext>
             </a:extLst>
           </p:cNvPr>
@@ -7495,7 +7517,7 @@
           <p:cNvPr id="17" name="">
             <a:extLst xmlns:a="http://schemas.openxmlformats.org/drawingml/2006/main">
               <a:ext uri="{FF2B5EF4-FFF2-40B4-BE49-F238E27FC236}">
-                <a16:creationId xmlns:a16="http://schemas.microsoft.com/office/drawing/2014/main" id="{72C559E4-4AD2-4646-A10B-4733D90FCDB2}"/>
+                <a16:creationId xmlns:a16="http://schemas.microsoft.com/office/drawing/2014/main" id="{E2B84851-77FA-4F6E-B729-8BBC61A47D17}"/>
               </a:ext>
             </a:extLst>
           </p:cNvPr>
@@ -7553,7 +7575,7 @@
           <p:cNvPr id="18" name="">
             <a:extLst xmlns:a="http://schemas.openxmlformats.org/drawingml/2006/main">
               <a:ext uri="{FF2B5EF4-FFF2-40B4-BE49-F238E27FC236}">
-                <a16:creationId xmlns:a16="http://schemas.microsoft.com/office/drawing/2014/main" id="{A7A850A8-B9E5-45DC-A9D3-30BCF2CD0822}"/>
+                <a16:creationId xmlns:a16="http://schemas.microsoft.com/office/drawing/2014/main" id="{926DA26D-6182-463D-97D7-0170B52206CA}"/>
               </a:ext>
             </a:extLst>
           </p:cNvPr>
@@ -7611,7 +7633,7 @@
           <p:cNvPr id="19" name="">
             <a:extLst xmlns:a="http://schemas.openxmlformats.org/drawingml/2006/main">
               <a:ext uri="{FF2B5EF4-FFF2-40B4-BE49-F238E27FC236}">
-                <a16:creationId xmlns:a16="http://schemas.microsoft.com/office/drawing/2014/main" id="{DF563D05-0EA8-45D6-A80F-0BAA8D2FF955}"/>
+                <a16:creationId xmlns:a16="http://schemas.microsoft.com/office/drawing/2014/main" id="{38D0C960-538C-49EA-B21F-FB4EFC60E4CB}"/>
               </a:ext>
             </a:extLst>
           </p:cNvPr>
@@ -7650,7 +7672,7 @@
           <p:nvPr/>
         </p:nvPicPr>
         <p:blipFill>
-          <a:blip xmlns:r="http://schemas.openxmlformats.org/officeDocument/2006/relationships" xmlns:a="http://schemas.openxmlformats.org/drawingml/2006/main" r:embed="R3d14e116dd594e16"/>
+          <a:blip xmlns:r="http://schemas.openxmlformats.org/officeDocument/2006/relationships" xmlns:a="http://schemas.openxmlformats.org/drawingml/2006/main" r:embed="R1a39b7b6567f444e"/>
           <a:stretch xmlns:a="http://schemas.openxmlformats.org/drawingml/2006/main"/>
         </p:blipFill>
         <p:spPr>
@@ -7668,7 +7690,7 @@
           <p:cNvPr id="21" name="">
             <a:extLst xmlns:a="http://schemas.openxmlformats.org/drawingml/2006/main">
               <a:ext uri="{FF2B5EF4-FFF2-40B4-BE49-F238E27FC236}">
-                <a16:creationId xmlns:a16="http://schemas.microsoft.com/office/drawing/2014/main" id="{F7DEDA4A-C73C-42E5-9A35-6BCBD1D090CB}"/>
+                <a16:creationId xmlns:a16="http://schemas.microsoft.com/office/drawing/2014/main" id="{14A38A70-E858-480E-AB79-23FB42A2AB41}"/>
               </a:ext>
             </a:extLst>
           </p:cNvPr>
@@ -7715,7 +7737,7 @@
                 <a:latin typeface="Aptos"/>
                 <a:ea typeface="Aptos"/>
                 <a:cs typeface="Aptos"/>
-                <a:hlinkClick xmlns:r="http://schemas.openxmlformats.org/officeDocument/2006/relationships" r:id="R0c20c5f45b9442bf"/>
+                <a:hlinkClick xmlns:r="http://schemas.openxmlformats.org/officeDocument/2006/relationships" r:id="R1587b77e4f704c77"/>
               </a:rPr>
               <a:t>3-min demo</a:t>
             </a:r>
@@ -7727,7 +7749,7 @@
           <p:cNvPr id="22" name="">
             <a:extLst xmlns:a="http://schemas.openxmlformats.org/drawingml/2006/main">
               <a:ext uri="{FF2B5EF4-FFF2-40B4-BE49-F238E27FC236}">
-                <a16:creationId xmlns:a16="http://schemas.microsoft.com/office/drawing/2014/main" id="{729B8CFE-6C38-495D-B2FE-99FB6D914EF7}"/>
+                <a16:creationId xmlns:a16="http://schemas.microsoft.com/office/drawing/2014/main" id="{4CF40F47-26C7-46C7-9E44-763F141429FA}"/>
               </a:ext>
             </a:extLst>
           </p:cNvPr>
@@ -7766,7 +7788,7 @@
           <p:nvPr/>
         </p:nvPicPr>
         <p:blipFill>
-          <a:blip xmlns:r="http://schemas.openxmlformats.org/officeDocument/2006/relationships" xmlns:a="http://schemas.openxmlformats.org/drawingml/2006/main" r:embed="R982da05d7e804044"/>
+          <a:blip xmlns:r="http://schemas.openxmlformats.org/officeDocument/2006/relationships" xmlns:a="http://schemas.openxmlformats.org/drawingml/2006/main" r:embed="R25dae35e58d34698"/>
           <a:stretch xmlns:a="http://schemas.openxmlformats.org/drawingml/2006/main"/>
         </p:blipFill>
         <p:spPr>
@@ -7784,7 +7806,7 @@
           <p:cNvPr id="24" name="">
             <a:extLst xmlns:a="http://schemas.openxmlformats.org/drawingml/2006/main">
               <a:ext uri="{FF2B5EF4-FFF2-40B4-BE49-F238E27FC236}">
-                <a16:creationId xmlns:a16="http://schemas.microsoft.com/office/drawing/2014/main" id="{8B7F3954-595D-4A30-B07D-9638B3FC5CEF}"/>
+                <a16:creationId xmlns:a16="http://schemas.microsoft.com/office/drawing/2014/main" id="{8B4C731D-7699-4087-8E41-5034CB8C669C}"/>
               </a:ext>
             </a:extLst>
           </p:cNvPr>
@@ -7831,7 +7853,7 @@
                 <a:latin typeface="Aptos"/>
                 <a:ea typeface="Aptos"/>
                 <a:cs typeface="Aptos"/>
-                <a:hlinkClick xmlns:r="http://schemas.openxmlformats.org/officeDocument/2006/relationships" r:id="R611cebe61e8b43fa"/>
+                <a:hlinkClick xmlns:r="http://schemas.openxmlformats.org/officeDocument/2006/relationships" r:id="R80142e377c36487a"/>
               </a:rPr>
               <a:t>live app</a:t>
             </a:r>
@@ -7843,7 +7865,7 @@
           <p:cNvPr id="25" name="">
             <a:extLst xmlns:a="http://schemas.openxmlformats.org/drawingml/2006/main">
               <a:ext uri="{FF2B5EF4-FFF2-40B4-BE49-F238E27FC236}">
-                <a16:creationId xmlns:a16="http://schemas.microsoft.com/office/drawing/2014/main" id="{E834D3D1-7E97-4B90-842B-745F4D74D5F0}"/>
+                <a16:creationId xmlns:a16="http://schemas.microsoft.com/office/drawing/2014/main" id="{ECD456D2-78CB-4B03-8C1F-420850B3E9FF}"/>
               </a:ext>
             </a:extLst>
           </p:cNvPr>
@@ -7882,7 +7904,7 @@
           <p:nvPr/>
         </p:nvPicPr>
         <p:blipFill>
-          <a:blip xmlns:r="http://schemas.openxmlformats.org/officeDocument/2006/relationships" xmlns:a="http://schemas.openxmlformats.org/drawingml/2006/main" r:embed="R582935e7cbde4545"/>
+          <a:blip xmlns:r="http://schemas.openxmlformats.org/officeDocument/2006/relationships" xmlns:a="http://schemas.openxmlformats.org/drawingml/2006/main" r:embed="Ra8da334fd0354370"/>
           <a:stretch xmlns:a="http://schemas.openxmlformats.org/drawingml/2006/main"/>
         </p:blipFill>
         <p:spPr>
@@ -7900,7 +7922,7 @@
           <p:cNvPr id="27" name="">
             <a:extLst xmlns:a="http://schemas.openxmlformats.org/drawingml/2006/main">
               <a:ext uri="{FF2B5EF4-FFF2-40B4-BE49-F238E27FC236}">
-                <a16:creationId xmlns:a16="http://schemas.microsoft.com/office/drawing/2014/main" id="{AEF781C6-9969-467D-9381-39D3755090EF}"/>
+                <a16:creationId xmlns:a16="http://schemas.microsoft.com/office/drawing/2014/main" id="{3DD0A620-0BCD-4E0C-8659-1DA18C84095B}"/>
               </a:ext>
             </a:extLst>
           </p:cNvPr>
@@ -7947,7 +7969,7 @@
                 <a:latin typeface="Aptos"/>
                 <a:ea typeface="Aptos"/>
                 <a:cs typeface="Aptos"/>
-                <a:hlinkClick xmlns:r="http://schemas.openxmlformats.org/officeDocument/2006/relationships" r:id="R09064edc30d44d5b"/>
+                <a:hlinkClick xmlns:r="http://schemas.openxmlformats.org/officeDocument/2006/relationships" r:id="R6e209b1a323346e9"/>
               </a:rPr>
               <a:t>proof receipt</a:t>
             </a:r>
@@ -7959,7 +7981,7 @@
           <p:cNvPr id="28" name="">
             <a:extLst xmlns:a="http://schemas.openxmlformats.org/drawingml/2006/main">
               <a:ext uri="{FF2B5EF4-FFF2-40B4-BE49-F238E27FC236}">
-                <a16:creationId xmlns:a16="http://schemas.microsoft.com/office/drawing/2014/main" id="{54F1B054-E875-46A2-A2EA-D1F863D6F4CB}"/>
+                <a16:creationId xmlns:a16="http://schemas.microsoft.com/office/drawing/2014/main" id="{68EDA4FC-5F4C-408C-9AE2-31D79EC8E60C}"/>
               </a:ext>
             </a:extLst>
           </p:cNvPr>
@@ -8015,7 +8037,7 @@
     </p:spTree>
     <p:extLst>
       <p:ext uri="{BB962C8B-B14F-4D97-AF65-F5344CB8AC3E}">
-        <p14:creationId xmlns:p14="http://schemas.microsoft.com/office/powerpoint/2010/main" val="618701487"/>
+        <p14:creationId xmlns:p14="http://schemas.microsoft.com/office/powerpoint/2010/main" val="993765519"/>
       </p:ext>
     </p:extLst>
   </p:cSld>

</xml_diff>